<commit_message>
fix: PPTX regenere sans emojis + PDF converti via LibreOffice
</commit_message>
<xml_diff>
--- a/Follow-Up_Fake_News_Detection.pptx
+++ b/Follow-Up_Fake_News_Detection.pptx
@@ -3167,14 +3167,14 @@
           <a:lstStyle/>
           <a:p>
             <a:pPr algn="ctr">
-              <a:defRPr sz="4000" b="1">
+              <a:defRPr sz="3800" b="1">
                 <a:solidFill>
                   <a:srgbClr val="FFFFFF"/>
                 </a:solidFill>
               </a:defRPr>
             </a:pPr>
             <a:r>
-              <a:t>🔍 DÉTECTION DE FAKE NEWS POLITIQUES</a:t>
+              <a:t>DETECTION DE FAKE NEWS POLITIQUES</a:t>
             </a:r>
           </a:p>
         </p:txBody>
@@ -3202,14 +3202,14 @@
           <a:lstStyle/>
           <a:p>
             <a:pPr algn="ctr">
-              <a:defRPr sz="2200" b="0">
+              <a:defRPr sz="2000" b="0">
                 <a:solidFill>
                   <a:srgbClr val="60A5FA"/>
                 </a:solidFill>
               </a:defRPr>
             </a:pPr>
             <a:r>
-              <a:t>Follow-Up — Projet Data Science &amp; Business Intelligence</a:t>
+              <a:t>Follow-Up  |  Projet Data Science &amp; Business Intelligence</a:t>
             </a:r>
           </a:p>
         </p:txBody>
@@ -3237,14 +3237,14 @@
           <a:lstStyle/>
           <a:p>
             <a:pPr algn="ctr">
-              <a:defRPr sz="1800" b="0">
+              <a:defRPr sz="1600" b="0">
                 <a:solidFill>
                   <a:srgbClr val="94A3B8"/>
                 </a:solidFill>
               </a:defRPr>
             </a:pPr>
             <a:r>
-              <a:t>Master 2 Epitech — Avril 2026</a:t>
+              <a:t>Master 2 Epitech  |  Avril 2026</a:t>
             </a:r>
           </a:p>
         </p:txBody>
@@ -3257,8 +3257,8 @@
         </p:nvSpPr>
         <p:spPr>
           <a:xfrm>
-            <a:off x="3200400" y="3840480"/>
-            <a:ext cx="5760720" cy="2011680"/>
+            <a:off x="3200400" y="3931920"/>
+            <a:ext cx="5760720" cy="1828800"/>
           </a:xfrm>
           <a:prstGeom prst="roundRect">
             <a:avLst/>
@@ -3266,10 +3266,8 @@
           <a:solidFill>
             <a:srgbClr val="1A243B"/>
           </a:solidFill>
-          <a:ln w="12700">
-            <a:solidFill>
-              <a:srgbClr val="33405C"/>
-            </a:solidFill>
+          <a:ln>
+            <a:noFill/>
           </a:ln>
         </p:spPr>
         <p:style>
@@ -3302,8 +3300,8 @@
         </p:nvSpPr>
         <p:spPr>
           <a:xfrm>
-            <a:off x="3474720" y="3977639"/>
-            <a:ext cx="5212080" cy="457200"/>
+            <a:off x="3474720" y="4069080"/>
+            <a:ext cx="5212080" cy="365760"/>
           </a:xfrm>
           <a:prstGeom prst="rect">
             <a:avLst/>
@@ -3317,7 +3315,7 @@
           <a:lstStyle/>
           <a:p>
             <a:pPr algn="ctr">
-              <a:defRPr sz="1400" b="1">
+              <a:defRPr sz="1300" b="1">
                 <a:solidFill>
                   <a:srgbClr val="60A5FA"/>
                 </a:solidFill>
@@ -3337,7 +3335,7 @@
         </p:nvSpPr>
         <p:spPr>
           <a:xfrm>
-            <a:off x="3474720" y="4434840"/>
+            <a:off x="3474720" y="4480560"/>
             <a:ext cx="5212080" cy="1097280"/>
           </a:xfrm>
           <a:prstGeom prst="rect">
@@ -3353,31 +3351,31 @@
           <a:p>
             <a:pPr>
               <a:spcAft>
-                <a:spcPts val="800"/>
+                <a:spcPts val="600"/>
               </a:spcAft>
-              <a:defRPr sz="1600">
+              <a:defRPr sz="1500">
                 <a:solidFill>
                   <a:srgbClr val="CBD5E1"/>
                 </a:solidFill>
               </a:defRPr>
             </a:pPr>
             <a:r>
-              <a:t>Alexis FAYAN  •  Yassin CHAAIRATE  •  Jacqueline MARIANADIN</a:t>
+              <a:t>Alexis FAYAN  |  Yassin CHAAIRATE  |  Jacqueline MARIANADIN</a:t>
             </a:r>
           </a:p>
           <a:p>
             <a:pPr>
               <a:spcAft>
-                <a:spcPts val="800"/>
+                <a:spcPts val="600"/>
               </a:spcAft>
-              <a:defRPr sz="1600">
+              <a:defRPr sz="1500">
                 <a:solidFill>
                   <a:srgbClr val="CBD5E1"/>
                 </a:solidFill>
               </a:defRPr>
             </a:pPr>
             <a:r>
-              <a:t>Ethan HARY  •  Aissatou-Blondin DIOP</a:t>
+              <a:t>Ethan HARY  |  Aissatou-Blondin DIOP</a:t>
             </a:r>
           </a:p>
         </p:txBody>
@@ -3474,14 +3472,14 @@
           <a:lstStyle/>
           <a:p>
             <a:pPr algn="l">
-              <a:defRPr sz="2800" b="1">
+              <a:defRPr sz="2600" b="1">
                 <a:solidFill>
                   <a:srgbClr val="FFFFFF"/>
                 </a:solidFill>
               </a:defRPr>
             </a:pPr>
             <a:r>
-              <a:t>01  PROBLÉMATIQUE &amp; CONTEXTE</a:t>
+              <a:t>01  PROBLEMATIQUE &amp; CONTEXTE</a:t>
             </a:r>
           </a:p>
         </p:txBody>
@@ -3494,7 +3492,7 @@
         </p:nvSpPr>
         <p:spPr>
           <a:xfrm>
-            <a:off x="731520" y="960120"/>
+            <a:off x="731520" y="914400"/>
             <a:ext cx="1828800" cy="36576"/>
           </a:xfrm>
           <a:prstGeom prst="roundRect">
@@ -3537,8 +3535,8 @@
         </p:nvSpPr>
         <p:spPr>
           <a:xfrm>
-            <a:off x="731520" y="1371600"/>
-            <a:ext cx="10698480" cy="1280160"/>
+            <a:off x="731520" y="1280160"/>
+            <a:ext cx="10698480" cy="1188720"/>
           </a:xfrm>
           <a:prstGeom prst="roundRect">
             <a:avLst/>
@@ -3546,10 +3544,8 @@
           <a:solidFill>
             <a:srgbClr val="1A243B"/>
           </a:solidFill>
-          <a:ln w="12700">
-            <a:solidFill>
-              <a:srgbClr val="33405C"/>
-            </a:solidFill>
+          <a:ln>
+            <a:noFill/>
           </a:ln>
         </p:spPr>
         <p:style>
@@ -3582,8 +3578,8 @@
         </p:nvSpPr>
         <p:spPr>
           <a:xfrm>
-            <a:off x="1097280" y="1417320"/>
-            <a:ext cx="10058400" cy="365760"/>
+            <a:off x="1097280" y="1371600"/>
+            <a:ext cx="10058400" cy="274320"/>
           </a:xfrm>
           <a:prstGeom prst="rect">
             <a:avLst/>
@@ -3597,14 +3593,14 @@
           <a:lstStyle/>
           <a:p>
             <a:pPr algn="l">
-              <a:defRPr sz="1400" b="1">
+              <a:defRPr sz="1200" b="1">
                 <a:solidFill>
                   <a:srgbClr val="60A5FA"/>
                 </a:solidFill>
               </a:defRPr>
             </a:pPr>
             <a:r>
-              <a:t>💡 PROBLÉMATIQUE</a:t>
+              <a:t>PROBLEMATIQUE</a:t>
             </a:r>
           </a:p>
         </p:txBody>
@@ -3617,8 +3613,8 @@
         </p:nvSpPr>
         <p:spPr>
           <a:xfrm>
-            <a:off x="1097280" y="1783080"/>
-            <a:ext cx="10058400" cy="731520"/>
+            <a:off x="1097280" y="1691640"/>
+            <a:ext cx="10058400" cy="640080"/>
           </a:xfrm>
           <a:prstGeom prst="rect">
             <a:avLst/>
@@ -3632,14 +3628,14 @@
           <a:lstStyle/>
           <a:p>
             <a:pPr algn="l">
-              <a:defRPr sz="2000" b="0">
+              <a:defRPr sz="1800" b="0">
                 <a:solidFill>
                   <a:srgbClr val="FFFFFF"/>
                 </a:solidFill>
               </a:defRPr>
             </a:pPr>
             <a:r>
-              <a:t>Peut-on détecter automatiquement les fake news politiques à partir du texte et des métadonnées du locuteur ?</a:t>
+              <a:t>Peut-on detecter automatiquement les fake news politiques a partir du texte et des metadonnees du locuteur ?</a:t>
             </a:r>
           </a:p>
         </p:txBody>
@@ -3652,8 +3648,8 @@
         </p:nvSpPr>
         <p:spPr>
           <a:xfrm>
-            <a:off x="731520" y="3017520"/>
-            <a:ext cx="5120640" cy="3200400"/>
+            <a:off x="731520" y="2834640"/>
+            <a:ext cx="5120640" cy="3474720"/>
           </a:xfrm>
           <a:prstGeom prst="roundRect">
             <a:avLst/>
@@ -3661,10 +3657,8 @@
           <a:solidFill>
             <a:srgbClr val="1A243B"/>
           </a:solidFill>
-          <a:ln w="12700">
-            <a:solidFill>
-              <a:srgbClr val="33405C"/>
-            </a:solidFill>
+          <a:ln>
+            <a:noFill/>
           </a:ln>
         </p:spPr>
         <p:style>
@@ -3697,8 +3691,8 @@
         </p:nvSpPr>
         <p:spPr>
           <a:xfrm>
-            <a:off x="1097280" y="3108960"/>
-            <a:ext cx="4389120" cy="365760"/>
+            <a:off x="1097280" y="2926080"/>
+            <a:ext cx="4389120" cy="274320"/>
           </a:xfrm>
           <a:prstGeom prst="rect">
             <a:avLst/>
@@ -3712,14 +3706,14 @@
           <a:lstStyle/>
           <a:p>
             <a:pPr algn="l">
-              <a:defRPr sz="1400" b="1">
+              <a:defRPr sz="1200" b="1">
                 <a:solidFill>
                   <a:srgbClr val="60A5FA"/>
                 </a:solidFill>
               </a:defRPr>
             </a:pPr>
             <a:r>
-              <a:t>📊 DATASETS</a:t>
+              <a:t>DATASETS</a:t>
             </a:r>
           </a:p>
         </p:txBody>
@@ -3732,8 +3726,8 @@
         </p:nvSpPr>
         <p:spPr>
           <a:xfrm>
-            <a:off x="1097280" y="3520440"/>
-            <a:ext cx="4389120" cy="2560320"/>
+            <a:off x="1097280" y="3291840"/>
+            <a:ext cx="4389120" cy="2743200"/>
           </a:xfrm>
           <a:prstGeom prst="rect">
             <a:avLst/>
@@ -3748,61 +3742,88 @@
           <a:p>
             <a:pPr>
               <a:spcAft>
-                <a:spcPts val="1000"/>
+                <a:spcPts val="600"/>
               </a:spcAft>
-              <a:defRPr sz="1500">
+              <a:defRPr sz="1400">
                 <a:solidFill>
                   <a:srgbClr val="CBD5E1"/>
                 </a:solidFill>
               </a:defRPr>
             </a:pPr>
             <a:r>
-              <a:t>LIAR Dataset — 12 800 déclarations politiques US</a:t>
+              <a:t>LIAR Dataset : 12 800 declarations politiques US</a:t>
             </a:r>
           </a:p>
           <a:p>
             <a:pPr>
               <a:spcAft>
-                <a:spcPts val="1000"/>
+                <a:spcPts val="600"/>
               </a:spcAft>
-              <a:defRPr sz="1500">
+              <a:defRPr sz="1400">
                 <a:solidFill>
                   <a:srgbClr val="CBD5E1"/>
                 </a:solidFill>
               </a:defRPr>
             </a:pPr>
             <a:r>
-              <a:t>Annotées par PolitiFact (fact-checkers pros)</a:t>
+              <a:t>Annotees par PolitiFact (fact-checkers pros)</a:t>
             </a:r>
           </a:p>
           <a:p>
             <a:pPr>
               <a:spcAft>
-                <a:spcPts val="1000"/>
+                <a:spcPts val="600"/>
               </a:spcAft>
-              <a:defRPr sz="1500">
+              <a:defRPr sz="1400">
                 <a:solidFill>
                   <a:srgbClr val="CBD5E1"/>
                 </a:solidFill>
               </a:defRPr>
             </a:pPr>
             <a:r>
-              <a:t>6 niveaux de véracité → simplifié en fake / real</a:t>
+              <a:t>6 niveaux de veracite -&gt; simplifie en fake / real</a:t>
             </a:r>
           </a:p>
           <a:p>
             <a:pPr>
               <a:spcAft>
-                <a:spcPts val="1000"/>
+                <a:spcPts val="600"/>
               </a:spcAft>
-              <a:defRPr sz="1500">
+              <a:defRPr sz="1400">
                 <a:solidFill>
                   <a:srgbClr val="CBD5E1"/>
                 </a:solidFill>
               </a:defRPr>
             </a:pPr>
-            <a:r>
-              <a:t>FakeNewsNet — ~1 000 articles (test généralisation)</a:t>
+          </a:p>
+          <a:p>
+            <a:pPr>
+              <a:spcAft>
+                <a:spcPts val="600"/>
+              </a:spcAft>
+              <a:defRPr sz="1400">
+                <a:solidFill>
+                  <a:srgbClr val="CBD5E1"/>
+                </a:solidFill>
+              </a:defRPr>
+            </a:pPr>
+            <a:r>
+              <a:t>FakeNewsNet : ~1 000 articles (generalisation)</a:t>
+            </a:r>
+          </a:p>
+          <a:p>
+            <a:pPr>
+              <a:spcAft>
+                <a:spcPts val="600"/>
+              </a:spcAft>
+              <a:defRPr sz="1400">
+                <a:solidFill>
+                  <a:srgbClr val="CBD5E1"/>
+                </a:solidFill>
+              </a:defRPr>
+            </a:pPr>
+            <a:r>
+              <a:t>Dataset jamais vu pendant l'entrainement</a:t>
             </a:r>
           </a:p>
         </p:txBody>
@@ -3815,8 +3836,8 @@
         </p:nvSpPr>
         <p:spPr>
           <a:xfrm>
-            <a:off x="6309360" y="3017520"/>
-            <a:ext cx="5120640" cy="3200400"/>
+            <a:off x="6309360" y="2834640"/>
+            <a:ext cx="5120640" cy="3474720"/>
           </a:xfrm>
           <a:prstGeom prst="roundRect">
             <a:avLst/>
@@ -3824,10 +3845,8 @@
           <a:solidFill>
             <a:srgbClr val="1A243B"/>
           </a:solidFill>
-          <a:ln w="12700">
-            <a:solidFill>
-              <a:srgbClr val="33405C"/>
-            </a:solidFill>
+          <a:ln>
+            <a:noFill/>
           </a:ln>
         </p:spPr>
         <p:style>
@@ -3860,8 +3879,8 @@
         </p:nvSpPr>
         <p:spPr>
           <a:xfrm>
-            <a:off x="6675120" y="3108960"/>
-            <a:ext cx="4389120" cy="365760"/>
+            <a:off x="6675120" y="2926080"/>
+            <a:ext cx="4389120" cy="274320"/>
           </a:xfrm>
           <a:prstGeom prst="rect">
             <a:avLst/>
@@ -3875,14 +3894,14 @@
           <a:lstStyle/>
           <a:p>
             <a:pPr algn="l">
-              <a:defRPr sz="1400" b="1">
+              <a:defRPr sz="1200" b="1">
                 <a:solidFill>
                   <a:srgbClr val="60A5FA"/>
                 </a:solidFill>
               </a:defRPr>
             </a:pPr>
             <a:r>
-              <a:t>🎯 APPROCHE</a:t>
+              <a:t>APPROCHE</a:t>
             </a:r>
           </a:p>
         </p:txBody>
@@ -3895,8 +3914,8 @@
         </p:nvSpPr>
         <p:spPr>
           <a:xfrm>
-            <a:off x="6675120" y="3520440"/>
-            <a:ext cx="4389120" cy="2560320"/>
+            <a:off x="6675120" y="3291840"/>
+            <a:ext cx="4389120" cy="2743200"/>
           </a:xfrm>
           <a:prstGeom prst="rect">
             <a:avLst/>
@@ -3911,9 +3930,9 @@
           <a:p>
             <a:pPr>
               <a:spcAft>
-                <a:spcPts val="1000"/>
+                <a:spcPts val="600"/>
               </a:spcAft>
-              <a:defRPr sz="1500">
+              <a:defRPr sz="1400">
                 <a:solidFill>
                   <a:srgbClr val="CBD5E1"/>
                 </a:solidFill>
@@ -3926,61 +3945,76 @@
           <a:p>
             <a:pPr>
               <a:spcAft>
-                <a:spcPts val="1000"/>
+                <a:spcPts val="600"/>
               </a:spcAft>
-              <a:defRPr sz="1500">
+              <a:defRPr sz="1400">
                 <a:solidFill>
                   <a:srgbClr val="CBD5E1"/>
                 </a:solidFill>
               </a:defRPr>
             </a:pPr>
             <a:r>
-              <a:t>TF-IDF + Word2Vec + métadonnées speaker</a:t>
+              <a:t>TF-IDF + Word2Vec + metadonnees speaker</a:t>
             </a:r>
           </a:p>
           <a:p>
             <a:pPr>
               <a:spcAft>
-                <a:spcPts val="1000"/>
+                <a:spcPts val="600"/>
               </a:spcAft>
-              <a:defRPr sz="1500">
+              <a:defRPr sz="1400">
                 <a:solidFill>
                   <a:srgbClr val="CBD5E1"/>
                 </a:solidFill>
               </a:defRPr>
             </a:pPr>
             <a:r>
-              <a:t>3 modèles classiques : LogReg, RF, XGBoost</a:t>
+              <a:t>3 modeles classiques : LogReg, RF, XGBoost</a:t>
             </a:r>
           </a:p>
           <a:p>
             <a:pPr>
               <a:spcAft>
-                <a:spcPts val="1000"/>
+                <a:spcPts val="600"/>
               </a:spcAft>
-              <a:defRPr sz="1500">
+              <a:defRPr sz="1400">
                 <a:solidFill>
                   <a:srgbClr val="CBD5E1"/>
                 </a:solidFill>
               </a:defRPr>
             </a:pPr>
             <a:r>
-              <a:t>1 modèle deep learning : BERT fine-tuné</a:t>
+              <a:t>1 modele deep learning : BERT fine-tune</a:t>
             </a:r>
           </a:p>
           <a:p>
             <a:pPr>
               <a:spcAft>
-                <a:spcPts val="1000"/>
+                <a:spcPts val="600"/>
               </a:spcAft>
-              <a:defRPr sz="1500">
+              <a:defRPr sz="1400">
                 <a:solidFill>
                   <a:srgbClr val="CBD5E1"/>
                 </a:solidFill>
               </a:defRPr>
             </a:pPr>
             <a:r>
-              <a:t>Évaluation : accuracy, F1, SHAP, biais</a:t>
+              <a:t>Cross-validation 5-fold + GridSearch</a:t>
+            </a:r>
+          </a:p>
+          <a:p>
+            <a:pPr>
+              <a:spcAft>
+                <a:spcPts val="600"/>
+              </a:spcAft>
+              <a:defRPr sz="1400">
+                <a:solidFill>
+                  <a:srgbClr val="CBD5E1"/>
+                </a:solidFill>
+              </a:defRPr>
+            </a:pPr>
+            <a:r>
+              <a:t>Evaluation : accuracy, F1, SHAP, biais</a:t>
             </a:r>
           </a:p>
         </p:txBody>
@@ -4077,14 +4111,14 @@
           <a:lstStyle/>
           <a:p>
             <a:pPr algn="l">
-              <a:defRPr sz="2800" b="1">
+              <a:defRPr sz="2600" b="1">
                 <a:solidFill>
                   <a:srgbClr val="FFFFFF"/>
                 </a:solidFill>
               </a:defRPr>
             </a:pPr>
             <a:r>
-              <a:t>02  MÉTHODOLOGIE</a:t>
+              <a:t>02  METHODOLOGIE</a:t>
             </a:r>
           </a:p>
         </p:txBody>
@@ -4097,7 +4131,7 @@
         </p:nvSpPr>
         <p:spPr>
           <a:xfrm>
-            <a:off x="731520" y="960120"/>
+            <a:off x="731520" y="914400"/>
             <a:ext cx="1828800" cy="36576"/>
           </a:xfrm>
           <a:prstGeom prst="roundRect">
@@ -4140,7 +4174,7 @@
         </p:nvSpPr>
         <p:spPr>
           <a:xfrm>
-            <a:off x="731520" y="1463040"/>
+            <a:off x="731520" y="1371600"/>
             <a:ext cx="2011680" cy="2560320"/>
           </a:xfrm>
           <a:prstGeom prst="roundRect">
@@ -4149,10 +4183,8 @@
           <a:solidFill>
             <a:srgbClr val="1A243B"/>
           </a:solidFill>
-          <a:ln w="12700">
-            <a:solidFill>
-              <a:srgbClr val="33405C"/>
-            </a:solidFill>
+          <a:ln>
+            <a:noFill/>
           </a:ln>
         </p:spPr>
         <p:style>
@@ -4185,7 +4217,7 @@
         </p:nvSpPr>
         <p:spPr>
           <a:xfrm>
-            <a:off x="1463040" y="1645920"/>
+            <a:off x="1463040" y="1554480"/>
             <a:ext cx="548640" cy="548640"/>
           </a:xfrm>
           <a:prstGeom prst="ellipse">
@@ -4237,7 +4269,7 @@
         </p:nvSpPr>
         <p:spPr>
           <a:xfrm>
-            <a:off x="868680" y="2331720"/>
+            <a:off x="868680" y="2240280"/>
             <a:ext cx="1737360" cy="365760"/>
           </a:xfrm>
           <a:prstGeom prst="rect">
@@ -4252,7 +4284,7 @@
           <a:lstStyle/>
           <a:p>
             <a:pPr algn="ctr">
-              <a:defRPr sz="1600" b="1">
+              <a:defRPr sz="1500" b="1">
                 <a:solidFill>
                   <a:srgbClr val="FFFFFF"/>
                 </a:solidFill>
@@ -4272,8 +4304,8 @@
         </p:nvSpPr>
         <p:spPr>
           <a:xfrm>
-            <a:off x="868680" y="2743200"/>
-            <a:ext cx="1737360" cy="1097280"/>
+            <a:off x="868680" y="2651760"/>
+            <a:ext cx="1737360" cy="274320"/>
           </a:xfrm>
           <a:prstGeom prst="rect">
             <a:avLst/>
@@ -4287,7 +4319,7 @@
           <a:lstStyle/>
           <a:p>
             <a:pPr algn="ctr">
-              <a:defRPr sz="1300" b="0">
+              <a:defRPr sz="1200" b="0">
                 <a:solidFill>
                   <a:srgbClr val="94A3B8"/>
                 </a:solidFill>
@@ -4296,11 +4328,73 @@
             <a:r>
               <a:t>Exploration des</a:t>
             </a:r>
-            <a:br/>
-            <a:r>
-              <a:t>données, stats,</a:t>
-            </a:r>
-            <a:br/>
+          </a:p>
+        </p:txBody>
+      </p:sp>
+      <p:sp>
+        <p:nvSpPr>
+          <p:cNvPr id="9" name="TextBox 8"/>
+          <p:cNvSpPr txBox="1"/>
+          <p:nvPr/>
+        </p:nvSpPr>
+        <p:spPr>
+          <a:xfrm>
+            <a:off x="868680" y="2907791"/>
+            <a:ext cx="1737360" cy="274320"/>
+          </a:xfrm>
+          <a:prstGeom prst="rect">
+            <a:avLst/>
+          </a:prstGeom>
+          <a:noFill/>
+        </p:spPr>
+        <p:txBody>
+          <a:bodyPr wrap="square">
+            <a:spAutoFit/>
+          </a:bodyPr>
+          <a:lstStyle/>
+          <a:p>
+            <a:pPr algn="ctr">
+              <a:defRPr sz="1200" b="0">
+                <a:solidFill>
+                  <a:srgbClr val="94A3B8"/>
+                </a:solidFill>
+              </a:defRPr>
+            </a:pPr>
+            <a:r>
+              <a:t>donnees, stats,</a:t>
+            </a:r>
+          </a:p>
+        </p:txBody>
+      </p:sp>
+      <p:sp>
+        <p:nvSpPr>
+          <p:cNvPr id="10" name="TextBox 9"/>
+          <p:cNvSpPr txBox="1"/>
+          <p:nvPr/>
+        </p:nvSpPr>
+        <p:spPr>
+          <a:xfrm>
+            <a:off x="868680" y="3163824"/>
+            <a:ext cx="1737360" cy="274320"/>
+          </a:xfrm>
+          <a:prstGeom prst="rect">
+            <a:avLst/>
+          </a:prstGeom>
+          <a:noFill/>
+        </p:spPr>
+        <p:txBody>
+          <a:bodyPr wrap="square">
+            <a:spAutoFit/>
+          </a:bodyPr>
+          <a:lstStyle/>
+          <a:p>
+            <a:pPr algn="ctr">
+              <a:defRPr sz="1200" b="0">
+                <a:solidFill>
+                  <a:srgbClr val="94A3B8"/>
+                </a:solidFill>
+              </a:defRPr>
+            </a:pPr>
             <a:r>
               <a:t>wordclouds</a:t>
             </a:r>
@@ -4309,13 +4403,13 @@
       </p:sp>
       <p:sp>
         <p:nvSpPr>
-          <p:cNvPr id="9" name="Rounded Rectangle 8"/>
+          <p:cNvPr id="11" name="Rounded Rectangle 10"/>
           <p:cNvSpPr/>
           <p:nvPr/>
         </p:nvSpPr>
         <p:spPr>
           <a:xfrm>
-            <a:off x="2971800" y="1463040"/>
+            <a:off x="2971800" y="1371600"/>
             <a:ext cx="2011680" cy="2560320"/>
           </a:xfrm>
           <a:prstGeom prst="roundRect">
@@ -4324,10 +4418,8 @@
           <a:solidFill>
             <a:srgbClr val="1A243B"/>
           </a:solidFill>
-          <a:ln w="12700">
-            <a:solidFill>
-              <a:srgbClr val="33405C"/>
-            </a:solidFill>
+          <a:ln>
+            <a:noFill/>
           </a:ln>
         </p:spPr>
         <p:style>
@@ -4354,13 +4446,13 @@
       </p:sp>
       <p:sp>
         <p:nvSpPr>
-          <p:cNvPr id="10" name="Oval 9"/>
+          <p:cNvPr id="12" name="Oval 11"/>
           <p:cNvSpPr/>
           <p:nvPr/>
         </p:nvSpPr>
         <p:spPr>
           <a:xfrm>
-            <a:off x="3703320" y="1645920"/>
+            <a:off x="3703320" y="1554480"/>
             <a:ext cx="548640" cy="548640"/>
           </a:xfrm>
           <a:prstGeom prst="ellipse">
@@ -4406,13 +4498,13 @@
       </p:sp>
       <p:sp>
         <p:nvSpPr>
-          <p:cNvPr id="11" name="TextBox 10"/>
+          <p:cNvPr id="13" name="TextBox 12"/>
           <p:cNvSpPr txBox="1"/>
           <p:nvPr/>
         </p:nvSpPr>
         <p:spPr>
           <a:xfrm>
-            <a:off x="3108960" y="2331720"/>
+            <a:off x="3108960" y="2240280"/>
             <a:ext cx="1737360" cy="365760"/>
           </a:xfrm>
           <a:prstGeom prst="rect">
@@ -4427,28 +4519,28 @@
           <a:lstStyle/>
           <a:p>
             <a:pPr algn="ctr">
-              <a:defRPr sz="1600" b="1">
+              <a:defRPr sz="1500" b="1">
                 <a:solidFill>
                   <a:srgbClr val="FFFFFF"/>
                 </a:solidFill>
               </a:defRPr>
             </a:pPr>
             <a:r>
-              <a:t>Prétraitement</a:t>
-            </a:r>
-          </a:p>
-        </p:txBody>
-      </p:sp>
-      <p:sp>
-        <p:nvSpPr>
-          <p:cNvPr id="12" name="TextBox 11"/>
+              <a:t>Pretraitement</a:t>
+            </a:r>
+          </a:p>
+        </p:txBody>
+      </p:sp>
+      <p:sp>
+        <p:nvSpPr>
+          <p:cNvPr id="14" name="TextBox 13"/>
           <p:cNvSpPr txBox="1"/>
           <p:nvPr/>
         </p:nvSpPr>
         <p:spPr>
           <a:xfrm>
-            <a:off x="3108960" y="2743200"/>
-            <a:ext cx="1737360" cy="1097280"/>
+            <a:off x="3108960" y="2651760"/>
+            <a:ext cx="1737360" cy="274320"/>
           </a:xfrm>
           <a:prstGeom prst="rect">
             <a:avLst/>
@@ -4462,7 +4554,7 @@
           <a:lstStyle/>
           <a:p>
             <a:pPr algn="ctr">
-              <a:defRPr sz="1300" b="0">
+              <a:defRPr sz="1200" b="0">
                 <a:solidFill>
                   <a:srgbClr val="94A3B8"/>
                 </a:solidFill>
@@ -4471,11 +4563,73 @@
             <a:r>
               <a:t>Nettoyage texte,</a:t>
             </a:r>
-            <a:br/>
+          </a:p>
+        </p:txBody>
+      </p:sp>
+      <p:sp>
+        <p:nvSpPr>
+          <p:cNvPr id="15" name="TextBox 14"/>
+          <p:cNvSpPr txBox="1"/>
+          <p:nvPr/>
+        </p:nvSpPr>
+        <p:spPr>
+          <a:xfrm>
+            <a:off x="3108960" y="2907791"/>
+            <a:ext cx="1737360" cy="274320"/>
+          </a:xfrm>
+          <a:prstGeom prst="rect">
+            <a:avLst/>
+          </a:prstGeom>
+          <a:noFill/>
+        </p:spPr>
+        <p:txBody>
+          <a:bodyPr wrap="square">
+            <a:spAutoFit/>
+          </a:bodyPr>
+          <a:lstStyle/>
+          <a:p>
+            <a:pPr algn="ctr">
+              <a:defRPr sz="1200" b="0">
+                <a:solidFill>
+                  <a:srgbClr val="94A3B8"/>
+                </a:solidFill>
+              </a:defRPr>
+            </a:pPr>
             <a:r>
               <a:t>mapping binaire</a:t>
             </a:r>
-            <a:br/>
+          </a:p>
+        </p:txBody>
+      </p:sp>
+      <p:sp>
+        <p:nvSpPr>
+          <p:cNvPr id="16" name="TextBox 15"/>
+          <p:cNvSpPr txBox="1"/>
+          <p:nvPr/>
+        </p:nvSpPr>
+        <p:spPr>
+          <a:xfrm>
+            <a:off x="3108960" y="3163824"/>
+            <a:ext cx="1737360" cy="274320"/>
+          </a:xfrm>
+          <a:prstGeom prst="rect">
+            <a:avLst/>
+          </a:prstGeom>
+          <a:noFill/>
+        </p:spPr>
+        <p:txBody>
+          <a:bodyPr wrap="square">
+            <a:spAutoFit/>
+          </a:bodyPr>
+          <a:lstStyle/>
+          <a:p>
+            <a:pPr algn="ctr">
+              <a:defRPr sz="1200" b="0">
+                <a:solidFill>
+                  <a:srgbClr val="94A3B8"/>
+                </a:solidFill>
+              </a:defRPr>
+            </a:pPr>
             <a:r>
               <a:t>fake/real</a:t>
             </a:r>
@@ -4484,13 +4638,13 @@
       </p:sp>
       <p:sp>
         <p:nvSpPr>
-          <p:cNvPr id="13" name="Rounded Rectangle 12"/>
+          <p:cNvPr id="17" name="Rounded Rectangle 16"/>
           <p:cNvSpPr/>
           <p:nvPr/>
         </p:nvSpPr>
         <p:spPr>
           <a:xfrm>
-            <a:off x="5212080" y="1463040"/>
+            <a:off x="5212080" y="1371600"/>
             <a:ext cx="2011680" cy="2560320"/>
           </a:xfrm>
           <a:prstGeom prst="roundRect">
@@ -4499,10 +4653,8 @@
           <a:solidFill>
             <a:srgbClr val="1A243B"/>
           </a:solidFill>
-          <a:ln w="12700">
-            <a:solidFill>
-              <a:srgbClr val="33405C"/>
-            </a:solidFill>
+          <a:ln>
+            <a:noFill/>
           </a:ln>
         </p:spPr>
         <p:style>
@@ -4529,13 +4681,13 @@
       </p:sp>
       <p:sp>
         <p:nvSpPr>
-          <p:cNvPr id="14" name="Oval 13"/>
+          <p:cNvPr id="18" name="Oval 17"/>
           <p:cNvSpPr/>
           <p:nvPr/>
         </p:nvSpPr>
         <p:spPr>
           <a:xfrm>
-            <a:off x="5943600" y="1645920"/>
+            <a:off x="5943600" y="1554480"/>
             <a:ext cx="548640" cy="548640"/>
           </a:xfrm>
           <a:prstGeom prst="ellipse">
@@ -4581,13 +4733,13 @@
       </p:sp>
       <p:sp>
         <p:nvSpPr>
-          <p:cNvPr id="15" name="TextBox 14"/>
+          <p:cNvPr id="19" name="TextBox 18"/>
           <p:cNvSpPr txBox="1"/>
           <p:nvPr/>
         </p:nvSpPr>
         <p:spPr>
           <a:xfrm>
-            <a:off x="5349240" y="2331720"/>
+            <a:off x="5349240" y="2240280"/>
             <a:ext cx="1737360" cy="365760"/>
           </a:xfrm>
           <a:prstGeom prst="rect">
@@ -4602,7 +4754,7 @@
           <a:lstStyle/>
           <a:p>
             <a:pPr algn="ctr">
-              <a:defRPr sz="1600" b="1">
+              <a:defRPr sz="1500" b="1">
                 <a:solidFill>
                   <a:srgbClr val="FFFFFF"/>
                 </a:solidFill>
@@ -4616,14 +4768,14 @@
       </p:sp>
       <p:sp>
         <p:nvSpPr>
-          <p:cNvPr id="16" name="TextBox 15"/>
+          <p:cNvPr id="20" name="TextBox 19"/>
           <p:cNvSpPr txBox="1"/>
           <p:nvPr/>
         </p:nvSpPr>
         <p:spPr>
           <a:xfrm>
-            <a:off x="5349240" y="2743200"/>
-            <a:ext cx="1737360" cy="1097280"/>
+            <a:off x="5349240" y="2651760"/>
+            <a:ext cx="1737360" cy="274320"/>
           </a:xfrm>
           <a:prstGeom prst="rect">
             <a:avLst/>
@@ -4637,7 +4789,7 @@
           <a:lstStyle/>
           <a:p>
             <a:pPr algn="ctr">
-              <a:defRPr sz="1300" b="0">
+              <a:defRPr sz="1200" b="0">
                 <a:solidFill>
                   <a:srgbClr val="94A3B8"/>
                 </a:solidFill>
@@ -4646,26 +4798,88 @@
             <a:r>
               <a:t>TF-IDF (10K),</a:t>
             </a:r>
-            <a:br/>
+          </a:p>
+        </p:txBody>
+      </p:sp>
+      <p:sp>
+        <p:nvSpPr>
+          <p:cNvPr id="21" name="TextBox 20"/>
+          <p:cNvSpPr txBox="1"/>
+          <p:nvPr/>
+        </p:nvSpPr>
+        <p:spPr>
+          <a:xfrm>
+            <a:off x="5349240" y="2907791"/>
+            <a:ext cx="1737360" cy="274320"/>
+          </a:xfrm>
+          <a:prstGeom prst="rect">
+            <a:avLst/>
+          </a:prstGeom>
+          <a:noFill/>
+        </p:spPr>
+        <p:txBody>
+          <a:bodyPr wrap="square">
+            <a:spAutoFit/>
+          </a:bodyPr>
+          <a:lstStyle/>
+          <a:p>
+            <a:pPr algn="ctr">
+              <a:defRPr sz="1200" b="0">
+                <a:solidFill>
+                  <a:srgbClr val="94A3B8"/>
+                </a:solidFill>
+              </a:defRPr>
+            </a:pPr>
             <a:r>
               <a:t>Word2Vec,</a:t>
             </a:r>
-            <a:br/>
-            <a:r>
-              <a:t>métadonnées</a:t>
-            </a:r>
-          </a:p>
-        </p:txBody>
-      </p:sp>
-      <p:sp>
-        <p:nvSpPr>
-          <p:cNvPr id="17" name="Rounded Rectangle 16"/>
+          </a:p>
+        </p:txBody>
+      </p:sp>
+      <p:sp>
+        <p:nvSpPr>
+          <p:cNvPr id="22" name="TextBox 21"/>
+          <p:cNvSpPr txBox="1"/>
+          <p:nvPr/>
+        </p:nvSpPr>
+        <p:spPr>
+          <a:xfrm>
+            <a:off x="5349240" y="3163824"/>
+            <a:ext cx="1737360" cy="274320"/>
+          </a:xfrm>
+          <a:prstGeom prst="rect">
+            <a:avLst/>
+          </a:prstGeom>
+          <a:noFill/>
+        </p:spPr>
+        <p:txBody>
+          <a:bodyPr wrap="square">
+            <a:spAutoFit/>
+          </a:bodyPr>
+          <a:lstStyle/>
+          <a:p>
+            <a:pPr algn="ctr">
+              <a:defRPr sz="1200" b="0">
+                <a:solidFill>
+                  <a:srgbClr val="94A3B8"/>
+                </a:solidFill>
+              </a:defRPr>
+            </a:pPr>
+            <a:r>
+              <a:t>metadonnees</a:t>
+            </a:r>
+          </a:p>
+        </p:txBody>
+      </p:sp>
+      <p:sp>
+        <p:nvSpPr>
+          <p:cNvPr id="23" name="Rounded Rectangle 22"/>
           <p:cNvSpPr/>
           <p:nvPr/>
         </p:nvSpPr>
         <p:spPr>
           <a:xfrm>
-            <a:off x="7452360" y="1463040"/>
+            <a:off x="7452360" y="1371600"/>
             <a:ext cx="2011680" cy="2560320"/>
           </a:xfrm>
           <a:prstGeom prst="roundRect">
@@ -4674,10 +4888,8 @@
           <a:solidFill>
             <a:srgbClr val="1A243B"/>
           </a:solidFill>
-          <a:ln w="12700">
-            <a:solidFill>
-              <a:srgbClr val="33405C"/>
-            </a:solidFill>
+          <a:ln>
+            <a:noFill/>
           </a:ln>
         </p:spPr>
         <p:style>
@@ -4704,13 +4916,13 @@
       </p:sp>
       <p:sp>
         <p:nvSpPr>
-          <p:cNvPr id="18" name="Oval 17"/>
+          <p:cNvPr id="24" name="Oval 23"/>
           <p:cNvSpPr/>
           <p:nvPr/>
         </p:nvSpPr>
         <p:spPr>
           <a:xfrm>
-            <a:off x="8183880" y="1645920"/>
+            <a:off x="8183880" y="1554480"/>
             <a:ext cx="548640" cy="548640"/>
           </a:xfrm>
           <a:prstGeom prst="ellipse">
@@ -4756,13 +4968,13 @@
       </p:sp>
       <p:sp>
         <p:nvSpPr>
-          <p:cNvPr id="19" name="TextBox 18"/>
+          <p:cNvPr id="25" name="TextBox 24"/>
           <p:cNvSpPr txBox="1"/>
           <p:nvPr/>
         </p:nvSpPr>
         <p:spPr>
           <a:xfrm>
-            <a:off x="7589520" y="2331720"/>
+            <a:off x="7589520" y="2240280"/>
             <a:ext cx="1737360" cy="365760"/>
           </a:xfrm>
           <a:prstGeom prst="rect">
@@ -4777,28 +4989,28 @@
           <a:lstStyle/>
           <a:p>
             <a:pPr algn="ctr">
-              <a:defRPr sz="1600" b="1">
+              <a:defRPr sz="1500" b="1">
                 <a:solidFill>
                   <a:srgbClr val="FFFFFF"/>
                 </a:solidFill>
               </a:defRPr>
             </a:pPr>
             <a:r>
-              <a:t>Modèles</a:t>
-            </a:r>
-          </a:p>
-        </p:txBody>
-      </p:sp>
-      <p:sp>
-        <p:nvSpPr>
-          <p:cNvPr id="20" name="TextBox 19"/>
+              <a:t>Modeles</a:t>
+            </a:r>
+          </a:p>
+        </p:txBody>
+      </p:sp>
+      <p:sp>
+        <p:nvSpPr>
+          <p:cNvPr id="26" name="TextBox 25"/>
           <p:cNvSpPr txBox="1"/>
           <p:nvPr/>
         </p:nvSpPr>
         <p:spPr>
           <a:xfrm>
-            <a:off x="7589520" y="2743200"/>
-            <a:ext cx="1737360" cy="1097280"/>
+            <a:off x="7589520" y="2651760"/>
+            <a:ext cx="1737360" cy="274320"/>
           </a:xfrm>
           <a:prstGeom prst="rect">
             <a:avLst/>
@@ -4812,7 +5024,7 @@
           <a:lstStyle/>
           <a:p>
             <a:pPr algn="ctr">
-              <a:defRPr sz="1300" b="0">
+              <a:defRPr sz="1200" b="0">
                 <a:solidFill>
                   <a:srgbClr val="94A3B8"/>
                 </a:solidFill>
@@ -4821,11 +5033,73 @@
             <a:r>
               <a:t>LogReg, RF,</a:t>
             </a:r>
-            <a:br/>
+          </a:p>
+        </p:txBody>
+      </p:sp>
+      <p:sp>
+        <p:nvSpPr>
+          <p:cNvPr id="27" name="TextBox 26"/>
+          <p:cNvSpPr txBox="1"/>
+          <p:nvPr/>
+        </p:nvSpPr>
+        <p:spPr>
+          <a:xfrm>
+            <a:off x="7589520" y="2907791"/>
+            <a:ext cx="1737360" cy="274320"/>
+          </a:xfrm>
+          <a:prstGeom prst="rect">
+            <a:avLst/>
+          </a:prstGeom>
+          <a:noFill/>
+        </p:spPr>
+        <p:txBody>
+          <a:bodyPr wrap="square">
+            <a:spAutoFit/>
+          </a:bodyPr>
+          <a:lstStyle/>
+          <a:p>
+            <a:pPr algn="ctr">
+              <a:defRPr sz="1200" b="0">
+                <a:solidFill>
+                  <a:srgbClr val="94A3B8"/>
+                </a:solidFill>
+              </a:defRPr>
+            </a:pPr>
             <a:r>
               <a:t>XGBoost +</a:t>
             </a:r>
-            <a:br/>
+          </a:p>
+        </p:txBody>
+      </p:sp>
+      <p:sp>
+        <p:nvSpPr>
+          <p:cNvPr id="28" name="TextBox 27"/>
+          <p:cNvSpPr txBox="1"/>
+          <p:nvPr/>
+        </p:nvSpPr>
+        <p:spPr>
+          <a:xfrm>
+            <a:off x="7589520" y="3163824"/>
+            <a:ext cx="1737360" cy="274320"/>
+          </a:xfrm>
+          <a:prstGeom prst="rect">
+            <a:avLst/>
+          </a:prstGeom>
+          <a:noFill/>
+        </p:spPr>
+        <p:txBody>
+          <a:bodyPr wrap="square">
+            <a:spAutoFit/>
+          </a:bodyPr>
+          <a:lstStyle/>
+          <a:p>
+            <a:pPr algn="ctr">
+              <a:defRPr sz="1200" b="0">
+                <a:solidFill>
+                  <a:srgbClr val="94A3B8"/>
+                </a:solidFill>
+              </a:defRPr>
+            </a:pPr>
             <a:r>
               <a:t>BERT</a:t>
             </a:r>
@@ -4834,13 +5108,13 @@
       </p:sp>
       <p:sp>
         <p:nvSpPr>
-          <p:cNvPr id="21" name="Rounded Rectangle 20"/>
+          <p:cNvPr id="29" name="Rounded Rectangle 28"/>
           <p:cNvSpPr/>
           <p:nvPr/>
         </p:nvSpPr>
         <p:spPr>
           <a:xfrm>
-            <a:off x="9692640" y="1463040"/>
+            <a:off x="9692640" y="1371600"/>
             <a:ext cx="2011680" cy="2560320"/>
           </a:xfrm>
           <a:prstGeom prst="roundRect">
@@ -4849,10 +5123,8 @@
           <a:solidFill>
             <a:srgbClr val="1A243B"/>
           </a:solidFill>
-          <a:ln w="12700">
-            <a:solidFill>
-              <a:srgbClr val="33405C"/>
-            </a:solidFill>
+          <a:ln>
+            <a:noFill/>
           </a:ln>
         </p:spPr>
         <p:style>
@@ -4879,13 +5151,13 @@
       </p:sp>
       <p:sp>
         <p:nvSpPr>
-          <p:cNvPr id="22" name="Oval 21"/>
+          <p:cNvPr id="30" name="Oval 29"/>
           <p:cNvSpPr/>
           <p:nvPr/>
         </p:nvSpPr>
         <p:spPr>
           <a:xfrm>
-            <a:off x="10424160" y="1645920"/>
+            <a:off x="10424160" y="1554480"/>
             <a:ext cx="548640" cy="548640"/>
           </a:xfrm>
           <a:prstGeom prst="ellipse">
@@ -4931,13 +5203,13 @@
       </p:sp>
       <p:sp>
         <p:nvSpPr>
-          <p:cNvPr id="23" name="TextBox 22"/>
+          <p:cNvPr id="31" name="TextBox 30"/>
           <p:cNvSpPr txBox="1"/>
           <p:nvPr/>
         </p:nvSpPr>
         <p:spPr>
           <a:xfrm>
-            <a:off x="9829800" y="2331720"/>
+            <a:off x="9829800" y="2240280"/>
             <a:ext cx="1737360" cy="365760"/>
           </a:xfrm>
           <a:prstGeom prst="rect">
@@ -4952,28 +5224,28 @@
           <a:lstStyle/>
           <a:p>
             <a:pPr algn="ctr">
-              <a:defRPr sz="1600" b="1">
+              <a:defRPr sz="1500" b="1">
                 <a:solidFill>
                   <a:srgbClr val="FFFFFF"/>
                 </a:solidFill>
               </a:defRPr>
             </a:pPr>
             <a:r>
-              <a:t>Évaluation</a:t>
-            </a:r>
-          </a:p>
-        </p:txBody>
-      </p:sp>
-      <p:sp>
-        <p:nvSpPr>
-          <p:cNvPr id="24" name="TextBox 23"/>
+              <a:t>Evaluation</a:t>
+            </a:r>
+          </a:p>
+        </p:txBody>
+      </p:sp>
+      <p:sp>
+        <p:nvSpPr>
+          <p:cNvPr id="32" name="TextBox 31"/>
           <p:cNvSpPr txBox="1"/>
           <p:nvPr/>
         </p:nvSpPr>
         <p:spPr>
           <a:xfrm>
-            <a:off x="9829800" y="2743200"/>
-            <a:ext cx="1737360" cy="1097280"/>
+            <a:off x="9829800" y="2651760"/>
+            <a:ext cx="1737360" cy="274320"/>
           </a:xfrm>
           <a:prstGeom prst="rect">
             <a:avLst/>
@@ -4987,7 +5259,7 @@
           <a:lstStyle/>
           <a:p>
             <a:pPr algn="ctr">
-              <a:defRPr sz="1300" b="0">
+              <a:defRPr sz="1200" b="0">
                 <a:solidFill>
                   <a:srgbClr val="94A3B8"/>
                 </a:solidFill>
@@ -4996,27 +5268,19 @@
             <a:r>
               <a:t>Cross-val 5-fold,</a:t>
             </a:r>
-            <a:br/>
-            <a:r>
-              <a:t>GridSearch,</a:t>
-            </a:r>
-            <a:br/>
-            <a:r>
-              <a:t>confusion matrix</a:t>
-            </a:r>
-          </a:p>
-        </p:txBody>
-      </p:sp>
-      <p:sp>
-        <p:nvSpPr>
-          <p:cNvPr id="25" name="TextBox 24"/>
+          </a:p>
+        </p:txBody>
+      </p:sp>
+      <p:sp>
+        <p:nvSpPr>
+          <p:cNvPr id="33" name="TextBox 32"/>
           <p:cNvSpPr txBox="1"/>
           <p:nvPr/>
         </p:nvSpPr>
         <p:spPr>
           <a:xfrm>
-            <a:off x="2720340" y="2377440"/>
-            <a:ext cx="274320" cy="365760"/>
+            <a:off x="9829800" y="2907791"/>
+            <a:ext cx="1737360" cy="274320"/>
           </a:xfrm>
           <a:prstGeom prst="rect">
             <a:avLst/>
@@ -5030,28 +5294,28 @@
           <a:lstStyle/>
           <a:p>
             <a:pPr algn="ctr">
-              <a:defRPr sz="2200" b="1">
-                <a:solidFill>
-                  <a:srgbClr val="60A5FA"/>
-                </a:solidFill>
-              </a:defRPr>
-            </a:pPr>
-            <a:r>
-              <a:t>→</a:t>
-            </a:r>
-          </a:p>
-        </p:txBody>
-      </p:sp>
-      <p:sp>
-        <p:nvSpPr>
-          <p:cNvPr id="26" name="TextBox 25"/>
+              <a:defRPr sz="1200" b="0">
+                <a:solidFill>
+                  <a:srgbClr val="94A3B8"/>
+                </a:solidFill>
+              </a:defRPr>
+            </a:pPr>
+            <a:r>
+              <a:t>GridSearch,</a:t>
+            </a:r>
+          </a:p>
+        </p:txBody>
+      </p:sp>
+      <p:sp>
+        <p:nvSpPr>
+          <p:cNvPr id="34" name="TextBox 33"/>
           <p:cNvSpPr txBox="1"/>
           <p:nvPr/>
         </p:nvSpPr>
         <p:spPr>
           <a:xfrm>
-            <a:off x="4960620" y="2377440"/>
-            <a:ext cx="274320" cy="365760"/>
+            <a:off x="9829800" y="3163824"/>
+            <a:ext cx="1737360" cy="274320"/>
           </a:xfrm>
           <a:prstGeom prst="rect">
             <a:avLst/>
@@ -5065,27 +5329,27 @@
           <a:lstStyle/>
           <a:p>
             <a:pPr algn="ctr">
-              <a:defRPr sz="2200" b="1">
-                <a:solidFill>
-                  <a:srgbClr val="60A5FA"/>
-                </a:solidFill>
-              </a:defRPr>
-            </a:pPr>
-            <a:r>
-              <a:t>→</a:t>
-            </a:r>
-          </a:p>
-        </p:txBody>
-      </p:sp>
-      <p:sp>
-        <p:nvSpPr>
-          <p:cNvPr id="27" name="TextBox 26"/>
+              <a:defRPr sz="1200" b="0">
+                <a:solidFill>
+                  <a:srgbClr val="94A3B8"/>
+                </a:solidFill>
+              </a:defRPr>
+            </a:pPr>
+            <a:r>
+              <a:t>confusion matrix</a:t>
+            </a:r>
+          </a:p>
+        </p:txBody>
+      </p:sp>
+      <p:sp>
+        <p:nvSpPr>
+          <p:cNvPr id="35" name="TextBox 34"/>
           <p:cNvSpPr txBox="1"/>
           <p:nvPr/>
         </p:nvSpPr>
         <p:spPr>
           <a:xfrm>
-            <a:off x="7200900" y="2377440"/>
+            <a:off x="2720340" y="2286000"/>
             <a:ext cx="274320" cy="365760"/>
           </a:xfrm>
           <a:prstGeom prst="rect">
@@ -5107,20 +5371,20 @@
               </a:defRPr>
             </a:pPr>
             <a:r>
-              <a:t>→</a:t>
-            </a:r>
-          </a:p>
-        </p:txBody>
-      </p:sp>
-      <p:sp>
-        <p:nvSpPr>
-          <p:cNvPr id="28" name="TextBox 27"/>
+              <a:t>&gt;</a:t>
+            </a:r>
+          </a:p>
+        </p:txBody>
+      </p:sp>
+      <p:sp>
+        <p:nvSpPr>
+          <p:cNvPr id="36" name="TextBox 35"/>
           <p:cNvSpPr txBox="1"/>
           <p:nvPr/>
         </p:nvSpPr>
         <p:spPr>
           <a:xfrm>
-            <a:off x="9441180" y="2377440"/>
+            <a:off x="4960620" y="2286000"/>
             <a:ext cx="274320" cy="365760"/>
           </a:xfrm>
           <a:prstGeom prst="rect">
@@ -5142,21 +5406,91 @@
               </a:defRPr>
             </a:pPr>
             <a:r>
-              <a:t>→</a:t>
-            </a:r>
-          </a:p>
-        </p:txBody>
-      </p:sp>
-      <p:sp>
-        <p:nvSpPr>
-          <p:cNvPr id="29" name="Rounded Rectangle 28"/>
+              <a:t>&gt;</a:t>
+            </a:r>
+          </a:p>
+        </p:txBody>
+      </p:sp>
+      <p:sp>
+        <p:nvSpPr>
+          <p:cNvPr id="37" name="TextBox 36"/>
+          <p:cNvSpPr txBox="1"/>
+          <p:nvPr/>
+        </p:nvSpPr>
+        <p:spPr>
+          <a:xfrm>
+            <a:off x="7200900" y="2286000"/>
+            <a:ext cx="274320" cy="365760"/>
+          </a:xfrm>
+          <a:prstGeom prst="rect">
+            <a:avLst/>
+          </a:prstGeom>
+          <a:noFill/>
+        </p:spPr>
+        <p:txBody>
+          <a:bodyPr wrap="square">
+            <a:spAutoFit/>
+          </a:bodyPr>
+          <a:lstStyle/>
+          <a:p>
+            <a:pPr algn="ctr">
+              <a:defRPr sz="2200" b="1">
+                <a:solidFill>
+                  <a:srgbClr val="60A5FA"/>
+                </a:solidFill>
+              </a:defRPr>
+            </a:pPr>
+            <a:r>
+              <a:t>&gt;</a:t>
+            </a:r>
+          </a:p>
+        </p:txBody>
+      </p:sp>
+      <p:sp>
+        <p:nvSpPr>
+          <p:cNvPr id="38" name="TextBox 37"/>
+          <p:cNvSpPr txBox="1"/>
+          <p:nvPr/>
+        </p:nvSpPr>
+        <p:spPr>
+          <a:xfrm>
+            <a:off x="9441180" y="2286000"/>
+            <a:ext cx="274320" cy="365760"/>
+          </a:xfrm>
+          <a:prstGeom prst="rect">
+            <a:avLst/>
+          </a:prstGeom>
+          <a:noFill/>
+        </p:spPr>
+        <p:txBody>
+          <a:bodyPr wrap="square">
+            <a:spAutoFit/>
+          </a:bodyPr>
+          <a:lstStyle/>
+          <a:p>
+            <a:pPr algn="ctr">
+              <a:defRPr sz="2200" b="1">
+                <a:solidFill>
+                  <a:srgbClr val="60A5FA"/>
+                </a:solidFill>
+              </a:defRPr>
+            </a:pPr>
+            <a:r>
+              <a:t>&gt;</a:t>
+            </a:r>
+          </a:p>
+        </p:txBody>
+      </p:sp>
+      <p:sp>
+        <p:nvSpPr>
+          <p:cNvPr id="39" name="Rounded Rectangle 38"/>
           <p:cNvSpPr/>
           <p:nvPr/>
         </p:nvSpPr>
         <p:spPr>
           <a:xfrm>
-            <a:off x="731520" y="4389120"/>
-            <a:ext cx="10698480" cy="2011680"/>
+            <a:off x="731520" y="4297680"/>
+            <a:ext cx="10698480" cy="2194560"/>
           </a:xfrm>
           <a:prstGeom prst="roundRect">
             <a:avLst/>
@@ -5164,10 +5498,8 @@
           <a:solidFill>
             <a:srgbClr val="1A243B"/>
           </a:solidFill>
-          <a:ln w="12700">
-            <a:solidFill>
-              <a:srgbClr val="33405C"/>
-            </a:solidFill>
+          <a:ln>
+            <a:noFill/>
           </a:ln>
         </p:spPr>
         <p:style>
@@ -5194,14 +5526,14 @@
       </p:sp>
       <p:sp>
         <p:nvSpPr>
-          <p:cNvPr id="30" name="TextBox 29"/>
+          <p:cNvPr id="40" name="TextBox 39"/>
           <p:cNvSpPr txBox="1"/>
           <p:nvPr/>
         </p:nvSpPr>
         <p:spPr>
           <a:xfrm>
-            <a:off x="1097280" y="4480560"/>
-            <a:ext cx="10058400" cy="365760"/>
+            <a:off x="1097280" y="4389120"/>
+            <a:ext cx="10058400" cy="274320"/>
           </a:xfrm>
           <a:prstGeom prst="rect">
             <a:avLst/>
@@ -5215,28 +5547,28 @@
           <a:lstStyle/>
           <a:p>
             <a:pPr algn="l">
-              <a:defRPr sz="1400" b="1">
+              <a:defRPr sz="1200" b="1">
                 <a:solidFill>
                   <a:srgbClr val="60A5FA"/>
                 </a:solidFill>
               </a:defRPr>
             </a:pPr>
             <a:r>
-              <a:t>🔧 TECHNIQUES CLÉS</a:t>
-            </a:r>
-          </a:p>
-        </p:txBody>
-      </p:sp>
-      <p:sp>
-        <p:nvSpPr>
-          <p:cNvPr id="31" name="TextBox 30"/>
+              <a:t>TECHNIQUES CLES</a:t>
+            </a:r>
+          </a:p>
+        </p:txBody>
+      </p:sp>
+      <p:sp>
+        <p:nvSpPr>
+          <p:cNvPr id="41" name="TextBox 40"/>
           <p:cNvSpPr txBox="1"/>
           <p:nvPr/>
         </p:nvSpPr>
         <p:spPr>
           <a:xfrm>
-            <a:off x="1097280" y="4892040"/>
-            <a:ext cx="10058400" cy="1371600"/>
+            <a:off x="1097280" y="4754880"/>
+            <a:ext cx="10058400" cy="1645920"/>
           </a:xfrm>
           <a:prstGeom prst="rect">
             <a:avLst/>
@@ -5253,14 +5585,14 @@
               <a:spcAft>
                 <a:spcPts val="600"/>
               </a:spcAft>
-              <a:defRPr sz="1400">
+              <a:defRPr sz="1300">
                 <a:solidFill>
                   <a:srgbClr val="CBD5E1"/>
                 </a:solidFill>
               </a:defRPr>
             </a:pPr>
             <a:r>
-              <a:t>TF-IDF : transforme le texte en vecteur de fréquences (10 000 features, unigrams + bigrams)</a:t>
+              <a:t>TF-IDF : transforme le texte en vecteur de frequences (10 000 features, unigrams + bigrams)</a:t>
             </a:r>
           </a:p>
           <a:p>
@@ -5268,14 +5600,14 @@
               <a:spcAft>
                 <a:spcPts val="600"/>
               </a:spcAft>
-              <a:defRPr sz="1400">
+              <a:defRPr sz="1300">
                 <a:solidFill>
                   <a:srgbClr val="CBD5E1"/>
                 </a:solidFill>
               </a:defRPr>
             </a:pPr>
             <a:r>
-              <a:t>Word2Vec : représentation dense du texte (300 dimensions) — comparé à TF-IDF</a:t>
+              <a:t>Word2Vec : representation dense du texte (300 dimensions) - compare a TF-IDF</a:t>
             </a:r>
           </a:p>
           <a:p>
@@ -5283,14 +5615,14 @@
               <a:spcAft>
                 <a:spcPts val="600"/>
               </a:spcAft>
-              <a:defRPr sz="1400">
+              <a:defRPr sz="1300">
                 <a:solidFill>
                   <a:srgbClr val="CBD5E1"/>
                 </a:solidFill>
               </a:defRPr>
             </a:pPr>
             <a:r>
-              <a:t>Cross-validation 5-fold : on divise le train en 5 parties pour valider la stabilité</a:t>
+              <a:t>Cross-validation 5-fold : on divise le train en 5 parties pour valider la stabilite</a:t>
             </a:r>
           </a:p>
           <a:p>
@@ -5298,14 +5630,14 @@
               <a:spcAft>
                 <a:spcPts val="600"/>
               </a:spcAft>
-              <a:defRPr sz="1400">
+              <a:defRPr sz="1300">
                 <a:solidFill>
                   <a:srgbClr val="CBD5E1"/>
                 </a:solidFill>
               </a:defRPr>
             </a:pPr>
             <a:r>
-              <a:t>SHAP values : on explique POURQUOI le modèle prédit fake ou real (interprétabilité)</a:t>
+              <a:t>SHAP values : on explique POURQUOI le modele predit fake ou real (interpretabilite)</a:t>
             </a:r>
           </a:p>
           <a:p>
@@ -5313,14 +5645,14 @@
               <a:spcAft>
                 <a:spcPts val="600"/>
               </a:spcAft>
-              <a:defRPr sz="1400">
+              <a:defRPr sz="1300">
                 <a:solidFill>
                   <a:srgbClr val="CBD5E1"/>
                 </a:solidFill>
               </a:defRPr>
             </a:pPr>
             <a:r>
-              <a:t>BERT : modèle deep learning pré-entraîné, fine-tuné avec early stopping + warmup</a:t>
+              <a:t>BERT : modele deep learning pre-entraine, fine-tune avec early stopping + warmup</a:t>
             </a:r>
           </a:p>
         </p:txBody>
@@ -5417,14 +5749,14 @@
           <a:lstStyle/>
           <a:p>
             <a:pPr algn="l">
-              <a:defRPr sz="2800" b="1">
+              <a:defRPr sz="2600" b="1">
                 <a:solidFill>
                   <a:srgbClr val="FFFFFF"/>
                 </a:solidFill>
               </a:defRPr>
             </a:pPr>
             <a:r>
-              <a:t>03  RÉSULTATS</a:t>
+              <a:t>03  RESULTATS</a:t>
             </a:r>
           </a:p>
         </p:txBody>
@@ -5437,7 +5769,7 @@
         </p:nvSpPr>
         <p:spPr>
           <a:xfrm>
-            <a:off x="731520" y="960120"/>
+            <a:off x="731520" y="914400"/>
             <a:ext cx="1828800" cy="36576"/>
           </a:xfrm>
           <a:prstGeom prst="roundRect">
@@ -5480,8 +5812,8 @@
         </p:nvSpPr>
         <p:spPr>
           <a:xfrm>
-            <a:off x="731520" y="1371600"/>
-            <a:ext cx="10698480" cy="1051560"/>
+            <a:off x="731520" y="1280160"/>
+            <a:ext cx="10698480" cy="1005840"/>
           </a:xfrm>
           <a:prstGeom prst="roundRect">
             <a:avLst/>
@@ -5489,10 +5821,8 @@
           <a:solidFill>
             <a:srgbClr val="1A243B"/>
           </a:solidFill>
-          <a:ln w="12700">
-            <a:solidFill>
-              <a:srgbClr val="33405C"/>
-            </a:solidFill>
+          <a:ln>
+            <a:noFill/>
           </a:ln>
         </p:spPr>
         <p:style>
@@ -5525,8 +5855,8 @@
         </p:nvSpPr>
         <p:spPr>
           <a:xfrm>
-            <a:off x="731520" y="1371600"/>
-            <a:ext cx="73152" cy="1051560"/>
+            <a:off x="731520" y="1280160"/>
+            <a:ext cx="73152" cy="1005840"/>
           </a:xfrm>
           <a:prstGeom prst="roundRect">
             <a:avLst/>
@@ -5568,8 +5898,8 @@
         </p:nvSpPr>
         <p:spPr>
           <a:xfrm>
-            <a:off x="1097280" y="1463040"/>
-            <a:ext cx="3200400" cy="365760"/>
+            <a:off x="1097280" y="1508760"/>
+            <a:ext cx="3200400" cy="457200"/>
           </a:xfrm>
           <a:prstGeom prst="rect">
             <a:avLst/>
@@ -5583,7 +5913,7 @@
           <a:lstStyle/>
           <a:p>
             <a:pPr algn="l">
-              <a:defRPr sz="1800" b="1">
+              <a:defRPr sz="1700" b="1">
                 <a:solidFill>
                   <a:srgbClr val="FFFFFF"/>
                 </a:solidFill>
@@ -5603,8 +5933,8 @@
         </p:nvSpPr>
         <p:spPr>
           <a:xfrm>
-            <a:off x="4572000" y="1417320"/>
-            <a:ext cx="1371600" cy="274320"/>
+            <a:off x="4572000" y="1325880"/>
+            <a:ext cx="1371600" cy="228600"/>
           </a:xfrm>
           <a:prstGeom prst="rect">
             <a:avLst/>
@@ -5618,7 +5948,7 @@
           <a:lstStyle/>
           <a:p>
             <a:pPr algn="ctr">
-              <a:defRPr sz="1100" b="0">
+              <a:defRPr sz="1000" b="0">
                 <a:solidFill>
                   <a:srgbClr val="94A3B8"/>
                 </a:solidFill>
@@ -5638,7 +5968,7 @@
         </p:nvSpPr>
         <p:spPr>
           <a:xfrm>
-            <a:off x="4572000" y="1691640"/>
+            <a:off x="4572000" y="1600200"/>
             <a:ext cx="1371600" cy="457200"/>
           </a:xfrm>
           <a:prstGeom prst="rect">
@@ -5653,7 +5983,7 @@
           <a:lstStyle/>
           <a:p>
             <a:pPr algn="ctr">
-              <a:defRPr sz="2600" b="1">
+              <a:defRPr sz="2400" b="1">
                 <a:solidFill>
                   <a:srgbClr val="3B82F6"/>
                 </a:solidFill>
@@ -5673,8 +6003,8 @@
         </p:nvSpPr>
         <p:spPr>
           <a:xfrm>
-            <a:off x="6400800" y="1417320"/>
-            <a:ext cx="1371600" cy="274320"/>
+            <a:off x="6400800" y="1325880"/>
+            <a:ext cx="1371600" cy="228600"/>
           </a:xfrm>
           <a:prstGeom prst="rect">
             <a:avLst/>
@@ -5688,7 +6018,7 @@
           <a:lstStyle/>
           <a:p>
             <a:pPr algn="ctr">
-              <a:defRPr sz="1100" b="0">
+              <a:defRPr sz="1000" b="0">
                 <a:solidFill>
                   <a:srgbClr val="94A3B8"/>
                 </a:solidFill>
@@ -5708,7 +6038,7 @@
         </p:nvSpPr>
         <p:spPr>
           <a:xfrm>
-            <a:off x="6400800" y="1691640"/>
+            <a:off x="6400800" y="1600200"/>
             <a:ext cx="1371600" cy="457200"/>
           </a:xfrm>
           <a:prstGeom prst="rect">
@@ -5723,7 +6053,7 @@
           <a:lstStyle/>
           <a:p>
             <a:pPr algn="ctr">
-              <a:defRPr sz="2600" b="1">
+              <a:defRPr sz="2400" b="1">
                 <a:solidFill>
                   <a:srgbClr val="3B82F6"/>
                 </a:solidFill>
@@ -5743,8 +6073,8 @@
         </p:nvSpPr>
         <p:spPr>
           <a:xfrm>
-            <a:off x="8229600" y="1600200"/>
-            <a:ext cx="2926080" cy="548640"/>
+            <a:off x="8229600" y="1508760"/>
+            <a:ext cx="2926080" cy="457200"/>
           </a:xfrm>
           <a:prstGeom prst="rect">
             <a:avLst/>
@@ -5765,7 +6095,7 @@
               </a:defRPr>
             </a:pPr>
             <a:r>
-              <a:t>Baseline solide, interprétable</a:t>
+              <a:t>Baseline solide, interpretable</a:t>
             </a:r>
           </a:p>
         </p:txBody>
@@ -5778,8 +6108,8 @@
         </p:nvSpPr>
         <p:spPr>
           <a:xfrm>
-            <a:off x="731520" y="2606040"/>
-            <a:ext cx="10698480" cy="1051560"/>
+            <a:off x="731520" y="2468880"/>
+            <a:ext cx="10698480" cy="1005840"/>
           </a:xfrm>
           <a:prstGeom prst="roundRect">
             <a:avLst/>
@@ -5787,10 +6117,8 @@
           <a:solidFill>
             <a:srgbClr val="1A243B"/>
           </a:solidFill>
-          <a:ln w="12700">
-            <a:solidFill>
-              <a:srgbClr val="33405C"/>
-            </a:solidFill>
+          <a:ln>
+            <a:noFill/>
           </a:ln>
         </p:spPr>
         <p:style>
@@ -5823,8 +6151,8 @@
         </p:nvSpPr>
         <p:spPr>
           <a:xfrm>
-            <a:off x="731520" y="2606040"/>
-            <a:ext cx="73152" cy="1051560"/>
+            <a:off x="731520" y="2468880"/>
+            <a:ext cx="73152" cy="1005840"/>
           </a:xfrm>
           <a:prstGeom prst="roundRect">
             <a:avLst/>
@@ -5867,7 +6195,7 @@
         <p:spPr>
           <a:xfrm>
             <a:off x="1097280" y="2697480"/>
-            <a:ext cx="3200400" cy="365760"/>
+            <a:ext cx="3200400" cy="457200"/>
           </a:xfrm>
           <a:prstGeom prst="rect">
             <a:avLst/>
@@ -5881,7 +6209,7 @@
           <a:lstStyle/>
           <a:p>
             <a:pPr algn="l">
-              <a:defRPr sz="1800" b="1">
+              <a:defRPr sz="1700" b="1">
                 <a:solidFill>
                   <a:srgbClr val="FFFFFF"/>
                 </a:solidFill>
@@ -5901,8 +6229,8 @@
         </p:nvSpPr>
         <p:spPr>
           <a:xfrm>
-            <a:off x="4572000" y="2651760"/>
-            <a:ext cx="1371600" cy="274320"/>
+            <a:off x="4572000" y="2514600"/>
+            <a:ext cx="1371600" cy="228600"/>
           </a:xfrm>
           <a:prstGeom prst="rect">
             <a:avLst/>
@@ -5916,7 +6244,7 @@
           <a:lstStyle/>
           <a:p>
             <a:pPr algn="ctr">
-              <a:defRPr sz="1100" b="0">
+              <a:defRPr sz="1000" b="0">
                 <a:solidFill>
                   <a:srgbClr val="94A3B8"/>
                 </a:solidFill>
@@ -5936,7 +6264,7 @@
         </p:nvSpPr>
         <p:spPr>
           <a:xfrm>
-            <a:off x="4572000" y="2926080"/>
+            <a:off x="4572000" y="2788920"/>
             <a:ext cx="1371600" cy="457200"/>
           </a:xfrm>
           <a:prstGeom prst="rect">
@@ -5951,7 +6279,7 @@
           <a:lstStyle/>
           <a:p>
             <a:pPr algn="ctr">
-              <a:defRPr sz="2600" b="1">
+              <a:defRPr sz="2400" b="1">
                 <a:solidFill>
                   <a:srgbClr val="22C55E"/>
                 </a:solidFill>
@@ -5971,8 +6299,8 @@
         </p:nvSpPr>
         <p:spPr>
           <a:xfrm>
-            <a:off x="6400800" y="2651760"/>
-            <a:ext cx="1371600" cy="274320"/>
+            <a:off x="6400800" y="2514600"/>
+            <a:ext cx="1371600" cy="228600"/>
           </a:xfrm>
           <a:prstGeom prst="rect">
             <a:avLst/>
@@ -5986,7 +6314,7 @@
           <a:lstStyle/>
           <a:p>
             <a:pPr algn="ctr">
-              <a:defRPr sz="1100" b="0">
+              <a:defRPr sz="1000" b="0">
                 <a:solidFill>
                   <a:srgbClr val="94A3B8"/>
                 </a:solidFill>
@@ -6006,7 +6334,7 @@
         </p:nvSpPr>
         <p:spPr>
           <a:xfrm>
-            <a:off x="6400800" y="2926080"/>
+            <a:off x="6400800" y="2788920"/>
             <a:ext cx="1371600" cy="457200"/>
           </a:xfrm>
           <a:prstGeom prst="rect">
@@ -6021,7 +6349,7 @@
           <a:lstStyle/>
           <a:p>
             <a:pPr algn="ctr">
-              <a:defRPr sz="2600" b="1">
+              <a:defRPr sz="2400" b="1">
                 <a:solidFill>
                   <a:srgbClr val="22C55E"/>
                 </a:solidFill>
@@ -6041,8 +6369,8 @@
         </p:nvSpPr>
         <p:spPr>
           <a:xfrm>
-            <a:off x="8229600" y="2834640"/>
-            <a:ext cx="2926080" cy="548640"/>
+            <a:off x="8229600" y="2697480"/>
+            <a:ext cx="2926080" cy="457200"/>
           </a:xfrm>
           <a:prstGeom prst="rect">
             <a:avLst/>
@@ -6063,7 +6391,7 @@
               </a:defRPr>
             </a:pPr>
             <a:r>
-              <a:t>Bon en ensembles, léger underfitting</a:t>
+              <a:t>Ensemble d'arbres, leger underfitting</a:t>
             </a:r>
           </a:p>
         </p:txBody>
@@ -6076,8 +6404,8 @@
         </p:nvSpPr>
         <p:spPr>
           <a:xfrm>
-            <a:off x="731520" y="3840480"/>
-            <a:ext cx="10698480" cy="1051560"/>
+            <a:off x="731520" y="3657600"/>
+            <a:ext cx="10698480" cy="1005840"/>
           </a:xfrm>
           <a:prstGeom prst="roundRect">
             <a:avLst/>
@@ -6085,10 +6413,8 @@
           <a:solidFill>
             <a:srgbClr val="1A243B"/>
           </a:solidFill>
-          <a:ln w="12700">
-            <a:solidFill>
-              <a:srgbClr val="33405C"/>
-            </a:solidFill>
+          <a:ln>
+            <a:noFill/>
           </a:ln>
         </p:spPr>
         <p:style>
@@ -6121,8 +6447,8 @@
         </p:nvSpPr>
         <p:spPr>
           <a:xfrm>
-            <a:off x="731520" y="3840480"/>
-            <a:ext cx="73152" cy="1051560"/>
+            <a:off x="731520" y="3657600"/>
+            <a:ext cx="73152" cy="1005840"/>
           </a:xfrm>
           <a:prstGeom prst="roundRect">
             <a:avLst/>
@@ -6164,8 +6490,8 @@
         </p:nvSpPr>
         <p:spPr>
           <a:xfrm>
-            <a:off x="1097280" y="3931920"/>
-            <a:ext cx="3200400" cy="365760"/>
+            <a:off x="1097280" y="3886200"/>
+            <a:ext cx="3200400" cy="457200"/>
           </a:xfrm>
           <a:prstGeom prst="rect">
             <a:avLst/>
@@ -6179,7 +6505,7 @@
           <a:lstStyle/>
           <a:p>
             <a:pPr algn="l">
-              <a:defRPr sz="1800" b="1">
+              <a:defRPr sz="1700" b="1">
                 <a:solidFill>
                   <a:srgbClr val="FFFFFF"/>
                 </a:solidFill>
@@ -6199,8 +6525,8 @@
         </p:nvSpPr>
         <p:spPr>
           <a:xfrm>
-            <a:off x="4572000" y="3886200"/>
-            <a:ext cx="1371600" cy="274320"/>
+            <a:off x="4572000" y="3703320"/>
+            <a:ext cx="1371600" cy="228600"/>
           </a:xfrm>
           <a:prstGeom prst="rect">
             <a:avLst/>
@@ -6214,7 +6540,7 @@
           <a:lstStyle/>
           <a:p>
             <a:pPr algn="ctr">
-              <a:defRPr sz="1100" b="0">
+              <a:defRPr sz="1000" b="0">
                 <a:solidFill>
                   <a:srgbClr val="94A3B8"/>
                 </a:solidFill>
@@ -6234,7 +6560,7 @@
         </p:nvSpPr>
         <p:spPr>
           <a:xfrm>
-            <a:off x="4572000" y="4160520"/>
+            <a:off x="4572000" y="3977640"/>
             <a:ext cx="1371600" cy="457200"/>
           </a:xfrm>
           <a:prstGeom prst="rect">
@@ -6249,7 +6575,7 @@
           <a:lstStyle/>
           <a:p>
             <a:pPr algn="ctr">
-              <a:defRPr sz="2600" b="1">
+              <a:defRPr sz="2400" b="1">
                 <a:solidFill>
                   <a:srgbClr val="F97316"/>
                 </a:solidFill>
@@ -6269,8 +6595,8 @@
         </p:nvSpPr>
         <p:spPr>
           <a:xfrm>
-            <a:off x="6400800" y="3886200"/>
-            <a:ext cx="1371600" cy="274320"/>
+            <a:off x="6400800" y="3703320"/>
+            <a:ext cx="1371600" cy="228600"/>
           </a:xfrm>
           <a:prstGeom prst="rect">
             <a:avLst/>
@@ -6284,7 +6610,7 @@
           <a:lstStyle/>
           <a:p>
             <a:pPr algn="ctr">
-              <a:defRPr sz="1100" b="0">
+              <a:defRPr sz="1000" b="0">
                 <a:solidFill>
                   <a:srgbClr val="94A3B8"/>
                 </a:solidFill>
@@ -6304,7 +6630,7 @@
         </p:nvSpPr>
         <p:spPr>
           <a:xfrm>
-            <a:off x="6400800" y="4160520"/>
+            <a:off x="6400800" y="3977640"/>
             <a:ext cx="1371600" cy="457200"/>
           </a:xfrm>
           <a:prstGeom prst="rect">
@@ -6319,7 +6645,7 @@
           <a:lstStyle/>
           <a:p>
             <a:pPr algn="ctr">
-              <a:defRPr sz="2600" b="1">
+              <a:defRPr sz="2400" b="1">
                 <a:solidFill>
                   <a:srgbClr val="F97316"/>
                 </a:solidFill>
@@ -6339,8 +6665,8 @@
         </p:nvSpPr>
         <p:spPr>
           <a:xfrm>
-            <a:off x="8229600" y="4069080"/>
-            <a:ext cx="2926080" cy="548640"/>
+            <a:off x="8229600" y="3886200"/>
+            <a:ext cx="2926080" cy="457200"/>
           </a:xfrm>
           <a:prstGeom prst="rect">
             <a:avLst/>
@@ -6361,7 +6687,7 @@
               </a:defRPr>
             </a:pPr>
             <a:r>
-              <a:t>🏆 MEILLEUR — exploite les métadonnées</a:t>
+              <a:t>MEILLEUR - exploite les metadonnees</a:t>
             </a:r>
           </a:p>
         </p:txBody>
@@ -6374,8 +6700,8 @@
         </p:nvSpPr>
         <p:spPr>
           <a:xfrm>
-            <a:off x="731520" y="5074920"/>
-            <a:ext cx="10698480" cy="1051560"/>
+            <a:off x="731520" y="4846320"/>
+            <a:ext cx="10698480" cy="1005840"/>
           </a:xfrm>
           <a:prstGeom prst="roundRect">
             <a:avLst/>
@@ -6383,10 +6709,8 @@
           <a:solidFill>
             <a:srgbClr val="1A243B"/>
           </a:solidFill>
-          <a:ln w="12700">
-            <a:solidFill>
-              <a:srgbClr val="33405C"/>
-            </a:solidFill>
+          <a:ln>
+            <a:noFill/>
           </a:ln>
         </p:spPr>
         <p:style>
@@ -6419,8 +6743,8 @@
         </p:nvSpPr>
         <p:spPr>
           <a:xfrm>
-            <a:off x="731520" y="5074920"/>
-            <a:ext cx="73152" cy="1051560"/>
+            <a:off x="731520" y="4846320"/>
+            <a:ext cx="73152" cy="1005840"/>
           </a:xfrm>
           <a:prstGeom prst="roundRect">
             <a:avLst/>
@@ -6462,8 +6786,8 @@
         </p:nvSpPr>
         <p:spPr>
           <a:xfrm>
-            <a:off x="1097280" y="5166360"/>
-            <a:ext cx="3200400" cy="365760"/>
+            <a:off x="1097280" y="5074920"/>
+            <a:ext cx="3200400" cy="457200"/>
           </a:xfrm>
           <a:prstGeom prst="rect">
             <a:avLst/>
@@ -6477,14 +6801,14 @@
           <a:lstStyle/>
           <a:p>
             <a:pPr algn="l">
-              <a:defRPr sz="1800" b="1">
+              <a:defRPr sz="1700" b="1">
                 <a:solidFill>
                   <a:srgbClr val="FFFFFF"/>
                 </a:solidFill>
               </a:defRPr>
             </a:pPr>
             <a:r>
-              <a:t>BERT</a:t>
+              <a:t>BERT (text only)</a:t>
             </a:r>
           </a:p>
         </p:txBody>
@@ -6497,8 +6821,8 @@
         </p:nvSpPr>
         <p:spPr>
           <a:xfrm>
-            <a:off x="4572000" y="5120640"/>
-            <a:ext cx="1371600" cy="274320"/>
+            <a:off x="4572000" y="4892040"/>
+            <a:ext cx="1371600" cy="228600"/>
           </a:xfrm>
           <a:prstGeom prst="rect">
             <a:avLst/>
@@ -6512,7 +6836,7 @@
           <a:lstStyle/>
           <a:p>
             <a:pPr algn="ctr">
-              <a:defRPr sz="1100" b="0">
+              <a:defRPr sz="1000" b="0">
                 <a:solidFill>
                   <a:srgbClr val="94A3B8"/>
                 </a:solidFill>
@@ -6532,7 +6856,7 @@
         </p:nvSpPr>
         <p:spPr>
           <a:xfrm>
-            <a:off x="4572000" y="5394960"/>
+            <a:off x="4572000" y="5166360"/>
             <a:ext cx="1371600" cy="457200"/>
           </a:xfrm>
           <a:prstGeom prst="rect">
@@ -6547,7 +6871,7 @@
           <a:lstStyle/>
           <a:p>
             <a:pPr algn="ctr">
-              <a:defRPr sz="2600" b="1">
+              <a:defRPr sz="2400" b="1">
                 <a:solidFill>
                   <a:srgbClr val="A78BFA"/>
                 </a:solidFill>
@@ -6567,8 +6891,8 @@
         </p:nvSpPr>
         <p:spPr>
           <a:xfrm>
-            <a:off x="6400800" y="5120640"/>
-            <a:ext cx="1371600" cy="274320"/>
+            <a:off x="6400800" y="4892040"/>
+            <a:ext cx="1371600" cy="228600"/>
           </a:xfrm>
           <a:prstGeom prst="rect">
             <a:avLst/>
@@ -6582,7 +6906,7 @@
           <a:lstStyle/>
           <a:p>
             <a:pPr algn="ctr">
-              <a:defRPr sz="1100" b="0">
+              <a:defRPr sz="1000" b="0">
                 <a:solidFill>
                   <a:srgbClr val="94A3B8"/>
                 </a:solidFill>
@@ -6602,7 +6926,7 @@
         </p:nvSpPr>
         <p:spPr>
           <a:xfrm>
-            <a:off x="6400800" y="5394960"/>
+            <a:off x="6400800" y="5166360"/>
             <a:ext cx="1371600" cy="457200"/>
           </a:xfrm>
           <a:prstGeom prst="rect">
@@ -6617,7 +6941,7 @@
           <a:lstStyle/>
           <a:p>
             <a:pPr algn="ctr">
-              <a:defRPr sz="2600" b="1">
+              <a:defRPr sz="2400" b="1">
                 <a:solidFill>
                   <a:srgbClr val="A78BFA"/>
                 </a:solidFill>
@@ -6637,8 +6961,8 @@
         </p:nvSpPr>
         <p:spPr>
           <a:xfrm>
-            <a:off x="8229600" y="5303520"/>
-            <a:ext cx="2926080" cy="548640"/>
+            <a:off x="8229600" y="5074920"/>
+            <a:ext cx="2926080" cy="457200"/>
           </a:xfrm>
           <a:prstGeom prst="rect">
             <a:avLst/>
@@ -6659,7 +6983,7 @@
               </a:defRPr>
             </a:pPr>
             <a:r>
-              <a:t>Text-only, pas de métadonnées</a:t>
+              <a:t>Deep learning, pas de metadonnees</a:t>
             </a:r>
           </a:p>
         </p:txBody>
@@ -6672,19 +6996,17 @@
         </p:nvSpPr>
         <p:spPr>
           <a:xfrm>
-            <a:off x="731520" y="5669280"/>
+            <a:off x="731520" y="5486400"/>
             <a:ext cx="10698480" cy="822960"/>
           </a:xfrm>
           <a:prstGeom prst="roundRect">
             <a:avLst/>
           </a:prstGeom>
           <a:solidFill>
-            <a:srgbClr val="1A243B"/>
+            <a:srgbClr val="1E3A2F"/>
           </a:solidFill>
-          <a:ln w="12700">
-            <a:solidFill>
-              <a:srgbClr val="1E3A2F"/>
-            </a:solidFill>
+          <a:ln>
+            <a:noFill/>
           </a:ln>
         </p:spPr>
         <p:style>
@@ -6717,7 +7039,7 @@
         </p:nvSpPr>
         <p:spPr>
           <a:xfrm>
-            <a:off x="1097280" y="5760720"/>
+            <a:off x="1097280" y="5577840"/>
             <a:ext cx="10058400" cy="640080"/>
           </a:xfrm>
           <a:prstGeom prst="rect">
@@ -6732,14 +7054,14 @@
           <a:lstStyle/>
           <a:p>
             <a:pPr algn="l">
-              <a:defRPr sz="1600" b="0">
+              <a:defRPr sz="1500" b="1">
                 <a:solidFill>
                   <a:srgbClr val="22C55E"/>
                 </a:solidFill>
               </a:defRPr>
             </a:pPr>
             <a:r>
-              <a:t>💡 Insight clé : les métadonnées (credit history) apportent +10 pts d'accuracy. Le texte seul ne suffit pas.</a:t>
+              <a:t>Insight cle : les metadonnees (credit history) apportent +10 pts d'accuracy. Le texte seul ne suffit pas.</a:t>
             </a:r>
           </a:p>
         </p:txBody>
@@ -6836,14 +7158,14 @@
           <a:lstStyle/>
           <a:p>
             <a:pPr algn="l">
-              <a:defRPr sz="2800" b="1">
+              <a:defRPr sz="2600" b="1">
                 <a:solidFill>
                   <a:srgbClr val="FFFFFF"/>
                 </a:solidFill>
               </a:defRPr>
             </a:pPr>
             <a:r>
-              <a:t>04  GÉNÉRALISATION &amp; BIAIS</a:t>
+              <a:t>04  GENERALISATION &amp; BIAIS</a:t>
             </a:r>
           </a:p>
         </p:txBody>
@@ -6856,7 +7178,7 @@
         </p:nvSpPr>
         <p:spPr>
           <a:xfrm>
-            <a:off x="731520" y="960120"/>
+            <a:off x="731520" y="914400"/>
             <a:ext cx="1828800" cy="36576"/>
           </a:xfrm>
           <a:prstGeom prst="roundRect">
@@ -6899,8 +7221,8 @@
         </p:nvSpPr>
         <p:spPr>
           <a:xfrm>
-            <a:off x="731520" y="1371600"/>
-            <a:ext cx="5120640" cy="4754880"/>
+            <a:off x="731520" y="1280160"/>
+            <a:ext cx="5120640" cy="5029200"/>
           </a:xfrm>
           <a:prstGeom prst="roundRect">
             <a:avLst/>
@@ -6908,10 +7230,8 @@
           <a:solidFill>
             <a:srgbClr val="1A243B"/>
           </a:solidFill>
-          <a:ln w="12700">
-            <a:solidFill>
-              <a:srgbClr val="33405C"/>
-            </a:solidFill>
+          <a:ln>
+            <a:noFill/>
           </a:ln>
         </p:spPr>
         <p:style>
@@ -6944,8 +7264,8 @@
         </p:nvSpPr>
         <p:spPr>
           <a:xfrm>
-            <a:off x="1097280" y="1463040"/>
-            <a:ext cx="4389120" cy="365760"/>
+            <a:off x="1097280" y="1371600"/>
+            <a:ext cx="4389120" cy="274320"/>
           </a:xfrm>
           <a:prstGeom prst="rect">
             <a:avLst/>
@@ -6959,14 +7279,14 @@
           <a:lstStyle/>
           <a:p>
             <a:pPr algn="l">
-              <a:defRPr sz="1400" b="1">
+              <a:defRPr sz="1200" b="1">
                 <a:solidFill>
                   <a:srgbClr val="60A5FA"/>
                 </a:solidFill>
               </a:defRPr>
             </a:pPr>
             <a:r>
-              <a:t>🌍 OUT-OF-DOMAIN (GÉNÉRALISATION)</a:t>
+              <a:t>OUT-OF-DOMAIN (GENERALISATION)</a:t>
             </a:r>
           </a:p>
         </p:txBody>
@@ -6979,8 +7299,8 @@
         </p:nvSpPr>
         <p:spPr>
           <a:xfrm>
-            <a:off x="1097280" y="1920240"/>
-            <a:ext cx="4389120" cy="3840480"/>
+            <a:off x="1097280" y="1783080"/>
+            <a:ext cx="4389120" cy="4114800"/>
           </a:xfrm>
           <a:prstGeom prst="rect">
             <a:avLst/>
@@ -6997,7 +7317,7 @@
               <a:spcAft>
                 <a:spcPts val="600"/>
               </a:spcAft>
-              <a:defRPr sz="1500">
+              <a:defRPr sz="1400">
                 <a:solidFill>
                   <a:srgbClr val="CBD5E1"/>
                 </a:solidFill>
@@ -7012,14 +7332,14 @@
               <a:spcAft>
                 <a:spcPts val="600"/>
               </a:spcAft>
-              <a:defRPr sz="1500">
+              <a:defRPr sz="1400">
                 <a:solidFill>
                   <a:srgbClr val="CBD5E1"/>
                 </a:solidFill>
               </a:defRPr>
             </a:pPr>
             <a:r>
-              <a:t>Dataset JAMAIS vu pendant l'entraînement</a:t>
+              <a:t>Dataset jamais vu pendant l'entrainement</a:t>
             </a:r>
           </a:p>
           <a:p>
@@ -7027,7 +7347,7 @@
               <a:spcAft>
                 <a:spcPts val="600"/>
               </a:spcAft>
-              <a:defRPr sz="1500">
+              <a:defRPr sz="1400">
                 <a:solidFill>
                   <a:srgbClr val="CBD5E1"/>
                 </a:solidFill>
@@ -7039,14 +7359,14 @@
               <a:spcAft>
                 <a:spcPts val="600"/>
               </a:spcAft>
-              <a:defRPr sz="1500">
+              <a:defRPr sz="1400">
                 <a:solidFill>
                   <a:srgbClr val="CBD5E1"/>
                 </a:solidFill>
               </a:defRPr>
             </a:pPr>
             <a:r>
-              <a:t>⚠️ Performance en baisse sur données externes</a:t>
+              <a:t>Performance en baisse sur donnees externes</a:t>
             </a:r>
           </a:p>
           <a:p>
@@ -7054,14 +7374,14 @@
               <a:spcAft>
                 <a:spcPts val="600"/>
               </a:spcAft>
-              <a:defRPr sz="1500">
+              <a:defRPr sz="1400">
                 <a:solidFill>
                   <a:srgbClr val="CBD5E1"/>
                 </a:solidFill>
               </a:defRPr>
             </a:pPr>
             <a:r>
-              <a:t>→ Les patterns LIAR ne se transfèrent pas bien</a:t>
+              <a:t>-&gt; Les patterns LIAR ne se transferent pas bien</a:t>
             </a:r>
           </a:p>
           <a:p>
@@ -7069,14 +7389,14 @@
               <a:spcAft>
                 <a:spcPts val="600"/>
               </a:spcAft>
-              <a:defRPr sz="1500">
+              <a:defRPr sz="1400">
                 <a:solidFill>
                   <a:srgbClr val="CBD5E1"/>
                 </a:solidFill>
               </a:defRPr>
             </a:pPr>
             <a:r>
-              <a:t>→ Vocabulaire et style différents entre datasets</a:t>
+              <a:t>-&gt; Vocabulaire et style differents entre datasets</a:t>
             </a:r>
           </a:p>
           <a:p>
@@ -7084,7 +7404,7 @@
               <a:spcAft>
                 <a:spcPts val="600"/>
               </a:spcAft>
-              <a:defRPr sz="1500">
+              <a:defRPr sz="1400">
                 <a:solidFill>
                   <a:srgbClr val="CBD5E1"/>
                 </a:solidFill>
@@ -7096,14 +7416,14 @@
               <a:spcAft>
                 <a:spcPts val="600"/>
               </a:spcAft>
-              <a:defRPr sz="1500">
+              <a:defRPr sz="1400">
                 <a:solidFill>
                   <a:srgbClr val="CBD5E1"/>
                 </a:solidFill>
               </a:defRPr>
             </a:pPr>
             <a:r>
-              <a:t>C'est le "domain shift" : le modèle a appris</a:t>
+              <a:t>Conclusion : le modele a appris des patterns</a:t>
             </a:r>
           </a:p>
           <a:p>
@@ -7111,14 +7431,14 @@
               <a:spcAft>
                 <a:spcPts val="600"/>
               </a:spcAft>
-              <a:defRPr sz="1500">
+              <a:defRPr sz="1400">
                 <a:solidFill>
                   <a:srgbClr val="CBD5E1"/>
                 </a:solidFill>
               </a:defRPr>
             </a:pPr>
             <a:r>
-              <a:t>des patterns spécifiques à LIAR, pas universels</a:t>
+              <a:t>specifiques a LIAR, pas des regles universelles</a:t>
             </a:r>
           </a:p>
         </p:txBody>
@@ -7131,8 +7451,8 @@
         </p:nvSpPr>
         <p:spPr>
           <a:xfrm>
-            <a:off x="6309360" y="1371600"/>
-            <a:ext cx="5120640" cy="4754880"/>
+            <a:off x="6309360" y="1280160"/>
+            <a:ext cx="5120640" cy="5029200"/>
           </a:xfrm>
           <a:prstGeom prst="roundRect">
             <a:avLst/>
@@ -7140,10 +7460,8 @@
           <a:solidFill>
             <a:srgbClr val="1A243B"/>
           </a:solidFill>
-          <a:ln w="12700">
-            <a:solidFill>
-              <a:srgbClr val="33405C"/>
-            </a:solidFill>
+          <a:ln>
+            <a:noFill/>
           </a:ln>
         </p:spPr>
         <p:style>
@@ -7176,8 +7494,8 @@
         </p:nvSpPr>
         <p:spPr>
           <a:xfrm>
-            <a:off x="6675120" y="1463040"/>
-            <a:ext cx="4389120" cy="365760"/>
+            <a:off x="6675120" y="1371600"/>
+            <a:ext cx="4389120" cy="274320"/>
           </a:xfrm>
           <a:prstGeom prst="rect">
             <a:avLst/>
@@ -7191,14 +7509,14 @@
           <a:lstStyle/>
           <a:p>
             <a:pPr algn="l">
-              <a:defRPr sz="1400" b="1">
+              <a:defRPr sz="1200" b="1">
                 <a:solidFill>
                   <a:srgbClr val="60A5FA"/>
                 </a:solidFill>
               </a:defRPr>
             </a:pPr>
             <a:r>
-              <a:t>⚖️ BIAIS &amp; FAIRNESS</a:t>
+              <a:t>BIAIS &amp; FAIRNESS</a:t>
             </a:r>
           </a:p>
         </p:txBody>
@@ -7211,8 +7529,8 @@
         </p:nvSpPr>
         <p:spPr>
           <a:xfrm>
-            <a:off x="6675120" y="1920240"/>
-            <a:ext cx="4389120" cy="3840480"/>
+            <a:off x="6675120" y="1783080"/>
+            <a:ext cx="4389120" cy="4114800"/>
           </a:xfrm>
           <a:prstGeom prst="rect">
             <a:avLst/>
@@ -7229,7 +7547,7 @@
               <a:spcAft>
                 <a:spcPts val="600"/>
               </a:spcAft>
-              <a:defRPr sz="1500">
+              <a:defRPr sz="1400">
                 <a:solidFill>
                   <a:srgbClr val="CBD5E1"/>
                 </a:solidFill>
@@ -7244,7 +7562,7 @@
               <a:spcAft>
                 <a:spcPts val="600"/>
               </a:spcAft>
-              <a:defRPr sz="1500">
+              <a:defRPr sz="1400">
                 <a:solidFill>
                   <a:srgbClr val="CBD5E1"/>
                 </a:solidFill>
@@ -7256,14 +7574,14 @@
               <a:spcAft>
                 <a:spcPts val="600"/>
               </a:spcAft>
-              <a:defRPr sz="1500">
+              <a:defRPr sz="1400">
                 <a:solidFill>
                   <a:srgbClr val="CBD5E1"/>
                 </a:solidFill>
               </a:defRPr>
             </a:pPr>
             <a:r>
-              <a:t>🔴 Problèmes identifiés :</a:t>
+              <a:t>Problemes identifies :</a:t>
             </a:r>
           </a:p>
           <a:p>
@@ -7271,14 +7589,14 @@
               <a:spcAft>
                 <a:spcPts val="600"/>
               </a:spcAft>
-              <a:defRPr sz="1500">
+              <a:defRPr sz="1400">
                 <a:solidFill>
                   <a:srgbClr val="CBD5E1"/>
                 </a:solidFill>
               </a:defRPr>
             </a:pPr>
             <a:r>
-              <a:t>→ Performances VARIENT selon le parti politique</a:t>
+              <a:t>-&gt; Performances varient selon le parti politique</a:t>
             </a:r>
           </a:p>
           <a:p>
@@ -7286,14 +7604,14 @@
               <a:spcAft>
                 <a:spcPts val="600"/>
               </a:spcAft>
-              <a:defRPr sz="1500">
+              <a:defRPr sz="1400">
                 <a:solidFill>
                   <a:srgbClr val="CBD5E1"/>
                 </a:solidFill>
               </a:defRPr>
             </a:pPr>
             <a:r>
-              <a:t>→ Surreprésentation de certains speakers</a:t>
+              <a:t>-&gt; Surrepresentation de certains speakers</a:t>
             </a:r>
           </a:p>
           <a:p>
@@ -7301,14 +7619,14 @@
               <a:spcAft>
                 <a:spcPts val="600"/>
               </a:spcAft>
-              <a:defRPr sz="1500">
+              <a:defRPr sz="1400">
                 <a:solidFill>
                   <a:srgbClr val="CBD5E1"/>
                 </a:solidFill>
               </a:defRPr>
             </a:pPr>
             <a:r>
-              <a:t>→ Le credit history encode l'historique du speaker</a:t>
+              <a:t>-&gt; Le credit history encode l'historique du speaker</a:t>
             </a:r>
           </a:p>
           <a:p>
@@ -7316,7 +7634,7 @@
               <a:spcAft>
                 <a:spcPts val="600"/>
               </a:spcAft>
-              <a:defRPr sz="1500">
+              <a:defRPr sz="1400">
                 <a:solidFill>
                   <a:srgbClr val="CBD5E1"/>
                 </a:solidFill>
@@ -7328,14 +7646,14 @@
               <a:spcAft>
                 <a:spcPts val="600"/>
               </a:spcAft>
-              <a:defRPr sz="1500">
+              <a:defRPr sz="1400">
                 <a:solidFill>
                   <a:srgbClr val="CBD5E1"/>
                 </a:solidFill>
               </a:defRPr>
             </a:pPr>
             <a:r>
-              <a:t>✅ Solutions proposées :</a:t>
+              <a:t>Solutions proposees :</a:t>
             </a:r>
           </a:p>
           <a:p>
@@ -7343,14 +7661,14 @@
               <a:spcAft>
                 <a:spcPts val="600"/>
               </a:spcAft>
-              <a:defRPr sz="1500">
+              <a:defRPr sz="1400">
                 <a:solidFill>
                   <a:srgbClr val="CBD5E1"/>
                 </a:solidFill>
               </a:defRPr>
             </a:pPr>
             <a:r>
-              <a:t>→ Audit régulier par sous-groupe</a:t>
+              <a:t>-&gt; Audit regulier par sous-groupe</a:t>
             </a:r>
           </a:p>
           <a:p>
@@ -7358,14 +7676,14 @@
               <a:spcAft>
                 <a:spcPts val="600"/>
               </a:spcAft>
-              <a:defRPr sz="1500">
+              <a:defRPr sz="1400">
                 <a:solidFill>
                   <a:srgbClr val="CBD5E1"/>
                 </a:solidFill>
               </a:defRPr>
             </a:pPr>
             <a:r>
-              <a:t>→ Humain dans la boucle (pas d'automatisation totale)</a:t>
+              <a:t>-&gt; Humain dans la boucle (pas d'auto totale)</a:t>
             </a:r>
           </a:p>
           <a:p>
@@ -7373,14 +7691,14 @@
               <a:spcAft>
                 <a:spcPts val="600"/>
               </a:spcAft>
-              <a:defRPr sz="1500">
+              <a:defRPr sz="1400">
                 <a:solidFill>
                   <a:srgbClr val="CBD5E1"/>
                 </a:solidFill>
               </a:defRPr>
             </a:pPr>
             <a:r>
-              <a:t>→ Transparence des critères de classification</a:t>
+              <a:t>-&gt; Transparence des criteres de classification</a:t>
             </a:r>
           </a:p>
         </p:txBody>
@@ -7477,14 +7795,14 @@
           <a:lstStyle/>
           <a:p>
             <a:pPr algn="l">
-              <a:defRPr sz="2800" b="1">
+              <a:defRPr sz="2600" b="1">
                 <a:solidFill>
                   <a:srgbClr val="FFFFFF"/>
                 </a:solidFill>
               </a:defRPr>
             </a:pPr>
             <a:r>
-              <a:t>05  CONCLUSION &amp; PROCHAINES ÉTAPES</a:t>
+              <a:t>05  CONCLUSION &amp; PROCHAINES ETAPES</a:t>
             </a:r>
           </a:p>
         </p:txBody>
@@ -7497,7 +7815,7 @@
         </p:nvSpPr>
         <p:spPr>
           <a:xfrm>
-            <a:off x="731520" y="960120"/>
+            <a:off x="731520" y="914400"/>
             <a:ext cx="1828800" cy="36576"/>
           </a:xfrm>
           <a:prstGeom prst="roundRect">
@@ -7540,7 +7858,7 @@
         </p:nvSpPr>
         <p:spPr>
           <a:xfrm>
-            <a:off x="731520" y="1371600"/>
+            <a:off x="731520" y="1280160"/>
             <a:ext cx="3474720" cy="2743200"/>
           </a:xfrm>
           <a:prstGeom prst="roundRect">
@@ -7549,10 +7867,8 @@
           <a:solidFill>
             <a:srgbClr val="1A243B"/>
           </a:solidFill>
-          <a:ln w="12700">
-            <a:solidFill>
-              <a:srgbClr val="33405C"/>
-            </a:solidFill>
+          <a:ln>
+            <a:noFill/>
           </a:ln>
         </p:spPr>
         <p:style>
@@ -7585,7 +7901,7 @@
         </p:nvSpPr>
         <p:spPr>
           <a:xfrm>
-            <a:off x="868680" y="1508760"/>
+            <a:off x="868680" y="1417320"/>
             <a:ext cx="548640" cy="365760"/>
           </a:xfrm>
           <a:prstGeom prst="roundRect">
@@ -7637,8 +7953,8 @@
         </p:nvSpPr>
         <p:spPr>
           <a:xfrm>
-            <a:off x="868680" y="2011680"/>
-            <a:ext cx="3200400" cy="914400"/>
+            <a:off x="868680" y="1920240"/>
+            <a:ext cx="3200400" cy="457200"/>
           </a:xfrm>
           <a:prstGeom prst="rect">
             <a:avLst/>
@@ -7659,11 +7975,7 @@
               </a:defRPr>
             </a:pPr>
             <a:r>
-              <a:t>Le modèle peut-il favoriser</a:t>
-            </a:r>
-            <a:br/>
-            <a:r>
-              <a:t>certains groupes ?</a:t>
+              <a:t>Favorise certains groupes ?</a:t>
             </a:r>
           </a:p>
         </p:txBody>
@@ -7676,8 +7988,8 @@
         </p:nvSpPr>
         <p:spPr>
           <a:xfrm>
-            <a:off x="868680" y="2926080"/>
-            <a:ext cx="3200400" cy="914400"/>
+            <a:off x="868680" y="2468880"/>
+            <a:ext cx="3200400" cy="274320"/>
           </a:xfrm>
           <a:prstGeom prst="rect">
             <a:avLst/>
@@ -7691,31 +8003,97 @@
           <a:lstStyle/>
           <a:p>
             <a:pPr algn="l">
-              <a:defRPr sz="1300" b="0">
+              <a:defRPr sz="1200" b="0">
                 <a:solidFill>
                   <a:srgbClr val="CBD5E1"/>
                 </a:solidFill>
               </a:defRPr>
             </a:pPr>
             <a:r>
-              <a:t>OUI — performances varient par parti.</a:t>
-            </a:r>
-            <a:br/>
-            <a:r>
-              <a:t>Il faut un humain dans la boucle.</a:t>
-            </a:r>
-          </a:p>
-        </p:txBody>
-      </p:sp>
-      <p:sp>
-        <p:nvSpPr>
-          <p:cNvPr id="9" name="Rounded Rectangle 8"/>
+              <a:t>OUI - performances varient par</a:t>
+            </a:r>
+          </a:p>
+        </p:txBody>
+      </p:sp>
+      <p:sp>
+        <p:nvSpPr>
+          <p:cNvPr id="9" name="TextBox 8"/>
+          <p:cNvSpPr txBox="1"/>
+          <p:nvPr/>
+        </p:nvSpPr>
+        <p:spPr>
+          <a:xfrm>
+            <a:off x="868680" y="2761488"/>
+            <a:ext cx="3200400" cy="274320"/>
+          </a:xfrm>
+          <a:prstGeom prst="rect">
+            <a:avLst/>
+          </a:prstGeom>
+          <a:noFill/>
+        </p:spPr>
+        <p:txBody>
+          <a:bodyPr wrap="square">
+            <a:spAutoFit/>
+          </a:bodyPr>
+          <a:lstStyle/>
+          <a:p>
+            <a:pPr algn="l">
+              <a:defRPr sz="1200" b="0">
+                <a:solidFill>
+                  <a:srgbClr val="CBD5E1"/>
+                </a:solidFill>
+              </a:defRPr>
+            </a:pPr>
+            <a:r>
+              <a:t>parti. Il faut un humain dans</a:t>
+            </a:r>
+          </a:p>
+        </p:txBody>
+      </p:sp>
+      <p:sp>
+        <p:nvSpPr>
+          <p:cNvPr id="10" name="TextBox 9"/>
+          <p:cNvSpPr txBox="1"/>
+          <p:nvPr/>
+        </p:nvSpPr>
+        <p:spPr>
+          <a:xfrm>
+            <a:off x="868680" y="3054096"/>
+            <a:ext cx="3200400" cy="274320"/>
+          </a:xfrm>
+          <a:prstGeom prst="rect">
+            <a:avLst/>
+          </a:prstGeom>
+          <a:noFill/>
+        </p:spPr>
+        <p:txBody>
+          <a:bodyPr wrap="square">
+            <a:spAutoFit/>
+          </a:bodyPr>
+          <a:lstStyle/>
+          <a:p>
+            <a:pPr algn="l">
+              <a:defRPr sz="1200" b="0">
+                <a:solidFill>
+                  <a:srgbClr val="CBD5E1"/>
+                </a:solidFill>
+              </a:defRPr>
+            </a:pPr>
+            <a:r>
+              <a:t>la boucle de decision.</a:t>
+            </a:r>
+          </a:p>
+        </p:txBody>
+      </p:sp>
+      <p:sp>
+        <p:nvSpPr>
+          <p:cNvPr id="11" name="Rounded Rectangle 10"/>
           <p:cNvSpPr/>
           <p:nvPr/>
         </p:nvSpPr>
         <p:spPr>
           <a:xfrm>
-            <a:off x="4480559" y="1371600"/>
+            <a:off x="4480559" y="1280160"/>
             <a:ext cx="3474720" cy="2743200"/>
           </a:xfrm>
           <a:prstGeom prst="roundRect">
@@ -7724,10 +8102,8 @@
           <a:solidFill>
             <a:srgbClr val="1A243B"/>
           </a:solidFill>
-          <a:ln w="12700">
-            <a:solidFill>
-              <a:srgbClr val="33405C"/>
-            </a:solidFill>
+          <a:ln>
+            <a:noFill/>
           </a:ln>
         </p:spPr>
         <p:style>
@@ -7754,13 +8130,13 @@
       </p:sp>
       <p:sp>
         <p:nvSpPr>
-          <p:cNvPr id="10" name="Rounded Rectangle 9"/>
+          <p:cNvPr id="12" name="Rounded Rectangle 11"/>
           <p:cNvSpPr/>
           <p:nvPr/>
         </p:nvSpPr>
         <p:spPr>
           <a:xfrm>
-            <a:off x="4617719" y="1508760"/>
+            <a:off x="4617719" y="1417320"/>
             <a:ext cx="548640" cy="365760"/>
           </a:xfrm>
           <a:prstGeom prst="roundRect">
@@ -7806,14 +8182,14 @@
       </p:sp>
       <p:sp>
         <p:nvSpPr>
-          <p:cNvPr id="11" name="TextBox 10"/>
+          <p:cNvPr id="13" name="TextBox 12"/>
           <p:cNvSpPr txBox="1"/>
           <p:nvPr/>
         </p:nvSpPr>
         <p:spPr>
           <a:xfrm>
-            <a:off x="4617719" y="2011680"/>
-            <a:ext cx="3200400" cy="914400"/>
+            <a:off x="4617719" y="1920240"/>
+            <a:ext cx="3200400" cy="457200"/>
           </a:xfrm>
           <a:prstGeom prst="rect">
             <a:avLst/>
@@ -7834,25 +8210,21 @@
               </a:defRPr>
             </a:pPr>
             <a:r>
-              <a:t>Les erreurs ont-elles des</a:t>
-            </a:r>
-            <a:br/>
-            <a:r>
-              <a:t>conséquences graves ?</a:t>
-            </a:r>
-          </a:p>
-        </p:txBody>
-      </p:sp>
-      <p:sp>
-        <p:nvSpPr>
-          <p:cNvPr id="12" name="TextBox 11"/>
+              <a:t>Erreurs consequentes ?</a:t>
+            </a:r>
+          </a:p>
+        </p:txBody>
+      </p:sp>
+      <p:sp>
+        <p:nvSpPr>
+          <p:cNvPr id="14" name="TextBox 13"/>
           <p:cNvSpPr txBox="1"/>
           <p:nvPr/>
         </p:nvSpPr>
         <p:spPr>
           <a:xfrm>
-            <a:off x="4617719" y="2926080"/>
-            <a:ext cx="3200400" cy="914400"/>
+            <a:off x="4617719" y="2468880"/>
+            <a:ext cx="3200400" cy="274320"/>
           </a:xfrm>
           <a:prstGeom prst="rect">
             <a:avLst/>
@@ -7866,31 +8238,97 @@
           <a:lstStyle/>
           <a:p>
             <a:pPr algn="l">
-              <a:defRPr sz="1300" b="0">
+              <a:defRPr sz="1200" b="0">
                 <a:solidFill>
                   <a:srgbClr val="CBD5E1"/>
                 </a:solidFill>
               </a:defRPr>
             </a:pPr>
             <a:r>
-              <a:t>OUI — faux positifs = censure,</a:t>
-            </a:r>
-            <a:br/>
-            <a:r>
-              <a:t>faux négatifs = désinformation.</a:t>
-            </a:r>
-          </a:p>
-        </p:txBody>
-      </p:sp>
-      <p:sp>
-        <p:nvSpPr>
-          <p:cNvPr id="13" name="Rounded Rectangle 12"/>
+              <a:t>OUI - faux positifs = censure,</a:t>
+            </a:r>
+          </a:p>
+        </p:txBody>
+      </p:sp>
+      <p:sp>
+        <p:nvSpPr>
+          <p:cNvPr id="15" name="TextBox 14"/>
+          <p:cNvSpPr txBox="1"/>
+          <p:nvPr/>
+        </p:nvSpPr>
+        <p:spPr>
+          <a:xfrm>
+            <a:off x="4617719" y="2761488"/>
+            <a:ext cx="3200400" cy="274320"/>
+          </a:xfrm>
+          <a:prstGeom prst="rect">
+            <a:avLst/>
+          </a:prstGeom>
+          <a:noFill/>
+        </p:spPr>
+        <p:txBody>
+          <a:bodyPr wrap="square">
+            <a:spAutoFit/>
+          </a:bodyPr>
+          <a:lstStyle/>
+          <a:p>
+            <a:pPr algn="l">
+              <a:defRPr sz="1200" b="0">
+                <a:solidFill>
+                  <a:srgbClr val="CBD5E1"/>
+                </a:solidFill>
+              </a:defRPr>
+            </a:pPr>
+            <a:r>
+              <a:t>faux negatifs = desinformation.</a:t>
+            </a:r>
+          </a:p>
+        </p:txBody>
+      </p:sp>
+      <p:sp>
+        <p:nvSpPr>
+          <p:cNvPr id="16" name="TextBox 15"/>
+          <p:cNvSpPr txBox="1"/>
+          <p:nvPr/>
+        </p:nvSpPr>
+        <p:spPr>
+          <a:xfrm>
+            <a:off x="4617719" y="3054096"/>
+            <a:ext cx="3200400" cy="274320"/>
+          </a:xfrm>
+          <a:prstGeom prst="rect">
+            <a:avLst/>
+          </a:prstGeom>
+          <a:noFill/>
+        </p:spPr>
+        <p:txBody>
+          <a:bodyPr wrap="square">
+            <a:spAutoFit/>
+          </a:bodyPr>
+          <a:lstStyle/>
+          <a:p>
+            <a:pPr algn="l">
+              <a:defRPr sz="1200" b="0">
+                <a:solidFill>
+                  <a:srgbClr val="CBD5E1"/>
+                </a:solidFill>
+              </a:defRPr>
+            </a:pPr>
+            <a:r>
+              <a:t>Trop d'erreurs pour l'auto.</a:t>
+            </a:r>
+          </a:p>
+        </p:txBody>
+      </p:sp>
+      <p:sp>
+        <p:nvSpPr>
+          <p:cNvPr id="17" name="Rounded Rectangle 16"/>
           <p:cNvSpPr/>
           <p:nvPr/>
         </p:nvSpPr>
         <p:spPr>
           <a:xfrm>
-            <a:off x="8229600" y="1371600"/>
+            <a:off x="8229600" y="1280160"/>
             <a:ext cx="3474720" cy="2743200"/>
           </a:xfrm>
           <a:prstGeom prst="roundRect">
@@ -7899,10 +8337,8 @@
           <a:solidFill>
             <a:srgbClr val="1A243B"/>
           </a:solidFill>
-          <a:ln w="12700">
-            <a:solidFill>
-              <a:srgbClr val="33405C"/>
-            </a:solidFill>
+          <a:ln>
+            <a:noFill/>
           </a:ln>
         </p:spPr>
         <p:style>
@@ -7929,13 +8365,13 @@
       </p:sp>
       <p:sp>
         <p:nvSpPr>
-          <p:cNvPr id="14" name="Rounded Rectangle 13"/>
+          <p:cNvPr id="18" name="Rounded Rectangle 17"/>
           <p:cNvSpPr/>
           <p:nvPr/>
         </p:nvSpPr>
         <p:spPr>
           <a:xfrm>
-            <a:off x="8366760" y="1508760"/>
+            <a:off x="8366760" y="1417320"/>
             <a:ext cx="548640" cy="365760"/>
           </a:xfrm>
           <a:prstGeom prst="roundRect">
@@ -7981,14 +8417,14 @@
       </p:sp>
       <p:sp>
         <p:nvSpPr>
-          <p:cNvPr id="15" name="TextBox 14"/>
+          <p:cNvPr id="19" name="TextBox 18"/>
           <p:cNvSpPr txBox="1"/>
           <p:nvPr/>
         </p:nvSpPr>
         <p:spPr>
           <a:xfrm>
-            <a:off x="8366760" y="2011680"/>
-            <a:ext cx="3200400" cy="914400"/>
+            <a:off x="8366760" y="1920240"/>
+            <a:ext cx="3200400" cy="457200"/>
           </a:xfrm>
           <a:prstGeom prst="rect">
             <a:avLst/>
@@ -8009,25 +8445,21 @@
               </a:defRPr>
             </a:pPr>
             <a:r>
-              <a:t>Peut-on détecter les fake news</a:t>
-            </a:r>
-            <a:br/>
-            <a:r>
-              <a:t>uniquement avec le texte ?</a:t>
-            </a:r>
-          </a:p>
-        </p:txBody>
-      </p:sp>
-      <p:sp>
-        <p:nvSpPr>
-          <p:cNvPr id="16" name="TextBox 15"/>
+              <a:t>Texte seul suffisant ?</a:t>
+            </a:r>
+          </a:p>
+        </p:txBody>
+      </p:sp>
+      <p:sp>
+        <p:nvSpPr>
+          <p:cNvPr id="20" name="TextBox 19"/>
           <p:cNvSpPr txBox="1"/>
           <p:nvPr/>
         </p:nvSpPr>
         <p:spPr>
           <a:xfrm>
-            <a:off x="8366760" y="2926080"/>
-            <a:ext cx="3200400" cy="914400"/>
+            <a:off x="8366760" y="2468880"/>
+            <a:ext cx="3200400" cy="274320"/>
           </a:xfrm>
           <a:prstGeom prst="rect">
             <a:avLst/>
@@ -8041,32 +8473,98 @@
           <a:lstStyle/>
           <a:p>
             <a:pPr algn="l">
-              <a:defRPr sz="1300" b="0">
+              <a:defRPr sz="1200" b="0">
                 <a:solidFill>
                   <a:srgbClr val="CBD5E1"/>
                 </a:solidFill>
               </a:defRPr>
             </a:pPr>
             <a:r>
-              <a:t>PARTIELLEMENT — le texte aide mais</a:t>
-            </a:r>
-            <a:br/>
-            <a:r>
-              <a:t>les métadonnées sont cruciales (+10 pts).</a:t>
-            </a:r>
-          </a:p>
-        </p:txBody>
-      </p:sp>
-      <p:sp>
-        <p:nvSpPr>
-          <p:cNvPr id="17" name="Rounded Rectangle 16"/>
+              <a:t>PARTIELLEMENT - le texte aide</a:t>
+            </a:r>
+          </a:p>
+        </p:txBody>
+      </p:sp>
+      <p:sp>
+        <p:nvSpPr>
+          <p:cNvPr id="21" name="TextBox 20"/>
+          <p:cNvSpPr txBox="1"/>
+          <p:nvPr/>
+        </p:nvSpPr>
+        <p:spPr>
+          <a:xfrm>
+            <a:off x="8366760" y="2761488"/>
+            <a:ext cx="3200400" cy="274320"/>
+          </a:xfrm>
+          <a:prstGeom prst="rect">
+            <a:avLst/>
+          </a:prstGeom>
+          <a:noFill/>
+        </p:spPr>
+        <p:txBody>
+          <a:bodyPr wrap="square">
+            <a:spAutoFit/>
+          </a:bodyPr>
+          <a:lstStyle/>
+          <a:p>
+            <a:pPr algn="l">
+              <a:defRPr sz="1200" b="0">
+                <a:solidFill>
+                  <a:srgbClr val="CBD5E1"/>
+                </a:solidFill>
+              </a:defRPr>
+            </a:pPr>
+            <a:r>
+              <a:t>mais les metadonnees sont</a:t>
+            </a:r>
+          </a:p>
+        </p:txBody>
+      </p:sp>
+      <p:sp>
+        <p:nvSpPr>
+          <p:cNvPr id="22" name="TextBox 21"/>
+          <p:cNvSpPr txBox="1"/>
+          <p:nvPr/>
+        </p:nvSpPr>
+        <p:spPr>
+          <a:xfrm>
+            <a:off x="8366760" y="3054096"/>
+            <a:ext cx="3200400" cy="274320"/>
+          </a:xfrm>
+          <a:prstGeom prst="rect">
+            <a:avLst/>
+          </a:prstGeom>
+          <a:noFill/>
+        </p:spPr>
+        <p:txBody>
+          <a:bodyPr wrap="square">
+            <a:spAutoFit/>
+          </a:bodyPr>
+          <a:lstStyle/>
+          <a:p>
+            <a:pPr algn="l">
+              <a:defRPr sz="1200" b="0">
+                <a:solidFill>
+                  <a:srgbClr val="CBD5E1"/>
+                </a:solidFill>
+              </a:defRPr>
+            </a:pPr>
+            <a:r>
+              <a:t>cruciales (+10 pts accuracy).</a:t>
+            </a:r>
+          </a:p>
+        </p:txBody>
+      </p:sp>
+      <p:sp>
+        <p:nvSpPr>
+          <p:cNvPr id="23" name="Rounded Rectangle 22"/>
           <p:cNvSpPr/>
           <p:nvPr/>
         </p:nvSpPr>
         <p:spPr>
           <a:xfrm>
-            <a:off x="731520" y="4480560"/>
-            <a:ext cx="10698480" cy="2011680"/>
+            <a:off x="731520" y="4389120"/>
+            <a:ext cx="10698480" cy="2103120"/>
           </a:xfrm>
           <a:prstGeom prst="roundRect">
             <a:avLst/>
@@ -8074,10 +8572,8 @@
           <a:solidFill>
             <a:srgbClr val="1A243B"/>
           </a:solidFill>
-          <a:ln w="12700">
-            <a:solidFill>
-              <a:srgbClr val="1A2A3B"/>
-            </a:solidFill>
+          <a:ln>
+            <a:noFill/>
           </a:ln>
         </p:spPr>
         <p:style>
@@ -8104,14 +8600,14 @@
       </p:sp>
       <p:sp>
         <p:nvSpPr>
-          <p:cNvPr id="18" name="TextBox 17"/>
+          <p:cNvPr id="24" name="TextBox 23"/>
           <p:cNvSpPr txBox="1"/>
           <p:nvPr/>
         </p:nvSpPr>
         <p:spPr>
           <a:xfrm>
-            <a:off x="1097280" y="4572000"/>
-            <a:ext cx="10058400" cy="365760"/>
+            <a:off x="1097280" y="4480560"/>
+            <a:ext cx="10058400" cy="274320"/>
           </a:xfrm>
           <a:prstGeom prst="rect">
             <a:avLst/>
@@ -8125,28 +8621,28 @@
           <a:lstStyle/>
           <a:p>
             <a:pPr algn="l">
-              <a:defRPr sz="1400" b="1">
+              <a:defRPr sz="1200" b="1">
                 <a:solidFill>
                   <a:srgbClr val="60A5FA"/>
                 </a:solidFill>
               </a:defRPr>
             </a:pPr>
             <a:r>
-              <a:t>🚀 PROCHAINES ÉTAPES POUR LA SOUTENANCE (17 avril)</a:t>
-            </a:r>
-          </a:p>
-        </p:txBody>
-      </p:sp>
-      <p:sp>
-        <p:nvSpPr>
-          <p:cNvPr id="19" name="TextBox 18"/>
+              <a:t>PROCHAINES ETAPES POUR LA SOUTENANCE (17 AVRIL)</a:t>
+            </a:r>
+          </a:p>
+        </p:txBody>
+      </p:sp>
+      <p:sp>
+        <p:nvSpPr>
+          <p:cNvPr id="25" name="TextBox 24"/>
           <p:cNvSpPr txBox="1"/>
           <p:nvPr/>
         </p:nvSpPr>
         <p:spPr>
           <a:xfrm>
-            <a:off x="1097280" y="5029200"/>
-            <a:ext cx="10058400" cy="1371600"/>
+            <a:off x="1097280" y="4846320"/>
+            <a:ext cx="10058400" cy="1554480"/>
           </a:xfrm>
           <a:prstGeom prst="rect">
             <a:avLst/>
@@ -8163,14 +8659,14 @@
               <a:spcAft>
                 <a:spcPts val="600"/>
               </a:spcAft>
-              <a:defRPr sz="1400">
+              <a:defRPr sz="1300">
                 <a:solidFill>
                   <a:srgbClr val="CBD5E1"/>
                 </a:solidFill>
               </a:defRPr>
             </a:pPr>
             <a:r>
-              <a:t>Ré-entraîner BERT avec les améliorations (early stopping, warmup, weight decay) et comparer</a:t>
+              <a:t>Re-entrainer BERT avec les ameliorations (early stopping, warmup, weight decay)</a:t>
             </a:r>
           </a:p>
           <a:p>
@@ -8178,14 +8674,14 @@
               <a:spcAft>
                 <a:spcPts val="600"/>
               </a:spcAft>
-              <a:defRPr sz="1400">
+              <a:defRPr sz="1300">
                 <a:solidFill>
                   <a:srgbClr val="CBD5E1"/>
                 </a:solidFill>
               </a:defRPr>
             </a:pPr>
             <a:r>
-              <a:t>Approfondir l'analyse SHAP et l'explicabilité des prédictions</a:t>
+              <a:t>Approfondir l'analyse SHAP et l'explicabilite des predictions</a:t>
             </a:r>
           </a:p>
           <a:p>
@@ -8193,14 +8689,14 @@
               <a:spcAft>
                 <a:spcPts val="600"/>
               </a:spcAft>
-              <a:defRPr sz="1400">
+              <a:defRPr sz="1300">
                 <a:solidFill>
                   <a:srgbClr val="CBD5E1"/>
                 </a:solidFill>
               </a:defRPr>
             </a:pPr>
             <a:r>
-              <a:t>Préparer les réponses aux questions du jury sur les limites et les biais</a:t>
+              <a:t>Preparer les reponses aux questions du jury sur les limites et les biais</a:t>
             </a:r>
           </a:p>
           <a:p>
@@ -8208,14 +8704,29 @@
               <a:spcAft>
                 <a:spcPts val="600"/>
               </a:spcAft>
-              <a:defRPr sz="1400">
+              <a:defRPr sz="1300">
                 <a:solidFill>
                   <a:srgbClr val="CBD5E1"/>
                 </a:solidFill>
               </a:defRPr>
             </a:pPr>
             <a:r>
-              <a:t>Finaliser les visualisations et la présentation orale</a:t>
+              <a:t>Finaliser les visualisations et la presentation orale</a:t>
+            </a:r>
+          </a:p>
+          <a:p>
+            <a:pPr>
+              <a:spcAft>
+                <a:spcPts val="600"/>
+              </a:spcAft>
+              <a:defRPr sz="1300">
+                <a:solidFill>
+                  <a:srgbClr val="CBD5E1"/>
+                </a:solidFill>
+              </a:defRPr>
+            </a:pPr>
+            <a:r>
+              <a:t>S'assurer que tout le groupe maitrise chaque section du notebook</a:t>
             </a:r>
           </a:p>
         </p:txBody>

</xml_diff>